<commit_message>
feat(#2679): add a full-width chart slide to the built-in template
A layout "Fred Chart Wide" (title and a chart placeholder across the
content width, no takeaway box) and its example slide, inserted after
"Fred Chart": a chart without commentary no longer leaves the takeaway
box empty. Deck edited with python-pptx (layout cloned, example chart
drawn by the builder); inventory regenerated with make builtin-inventory.
</commit_message>
<xml_diff>
--- a/libs/capabilities/fred-capability-ppt-filler/fred_capability_ppt_filler/builder/assets/fred_template.pptx
+++ b/libs/capabilities/fred-capability-ppt-filler/fred_capability_ppt_filler/builder/assets/fred_template.pptx
@@ -15,6 +15,7 @@
     <p:sldId id="263" r:id="rId9"/>
     <p:sldId id="264" r:id="rId10"/>
     <p:sldId id="265" r:id="rId11"/>
+    <p:sldId id="271" r:id="rId22"/>
     <p:sldId id="266" r:id="rId12"/>
     <p:sldId id="267" r:id="rId13"/>
     <p:sldId id="268" r:id="rId14"/>
@@ -398,6 +399,244 @@
 </c:chartSpace>
 </file>
 
+<file path=ppt/charts/chart2.xml><?xml version="1.0" encoding="utf-8"?>
+<c:chartSpace xmlns:c="http://schemas.openxmlformats.org/drawingml/2006/chart" xmlns:a="http://schemas.openxmlformats.org/drawingml/2006/main" xmlns:r="http://schemas.openxmlformats.org/officeDocument/2006/relationships">
+  <c:date1904 val="0"/>
+  <c:chart>
+    <c:autoTitleDeleted val="1"/>
+    <c:plotArea>
+      <c:barChart>
+        <c:barDir val="col"/>
+        <c:grouping val="clustered"/>
+        <c:ser>
+          <c:idx val="0"/>
+          <c:order val="0"/>
+          <c:tx>
+            <c:strRef>
+              <c:f>Sheet1!$B$1</c:f>
+              <c:strCache>
+                <c:ptCount val="1"/>
+                <c:pt idx="0">
+                  <c:v>2025</c:v>
+                </c:pt>
+              </c:strCache>
+            </c:strRef>
+          </c:tx>
+          <c:spPr>
+            <a:solidFill>
+              <a:schemeClr val="accent1"/>
+            </a:solidFill>
+          </c:spPr>
+          <c:cat>
+            <c:strRef>
+              <c:f>Sheet1!$A$2:$A$5</c:f>
+              <c:strCache>
+                <c:ptCount val="4"/>
+                <c:pt idx="0">
+                  <c:v>Q1</c:v>
+                </c:pt>
+                <c:pt idx="1">
+                  <c:v>Q2</c:v>
+                </c:pt>
+                <c:pt idx="2">
+                  <c:v>Q3</c:v>
+                </c:pt>
+                <c:pt idx="3">
+                  <c:v>Q4</c:v>
+                </c:pt>
+              </c:strCache>
+            </c:strRef>
+          </c:cat>
+          <c:val>
+            <c:numRef>
+              <c:f>Sheet1!$B$2:$B$5</c:f>
+              <c:numCache>
+                <c:formatCode>#,##0</c:formatCode>
+                <c:ptCount val="4"/>
+                <c:pt idx="0">
+                  <c:v>12.0</c:v>
+                </c:pt>
+                <c:pt idx="1">
+                  <c:v>15.0</c:v>
+                </c:pt>
+                <c:pt idx="2">
+                  <c:v>14.0</c:v>
+                </c:pt>
+                <c:pt idx="3">
+                  <c:v>18.0</c:v>
+                </c:pt>
+              </c:numCache>
+            </c:numRef>
+          </c:val>
+        </c:ser>
+        <c:ser>
+          <c:idx val="1"/>
+          <c:order val="1"/>
+          <c:tx>
+            <c:strRef>
+              <c:f>Sheet1!$C$1</c:f>
+              <c:strCache>
+                <c:ptCount val="1"/>
+                <c:pt idx="0">
+                  <c:v>2026</c:v>
+                </c:pt>
+              </c:strCache>
+            </c:strRef>
+          </c:tx>
+          <c:spPr>
+            <a:solidFill>
+              <a:schemeClr val="accent2"/>
+            </a:solidFill>
+          </c:spPr>
+          <c:cat>
+            <c:strRef>
+              <c:f>Sheet1!$A$2:$A$5</c:f>
+              <c:strCache>
+                <c:ptCount val="4"/>
+                <c:pt idx="0">
+                  <c:v>Q1</c:v>
+                </c:pt>
+                <c:pt idx="1">
+                  <c:v>Q2</c:v>
+                </c:pt>
+                <c:pt idx="2">
+                  <c:v>Q3</c:v>
+                </c:pt>
+                <c:pt idx="3">
+                  <c:v>Q4</c:v>
+                </c:pt>
+              </c:strCache>
+            </c:strRef>
+          </c:cat>
+          <c:val>
+            <c:numRef>
+              <c:f>Sheet1!$C$2:$C$5</c:f>
+              <c:numCache>
+                <c:formatCode>#,##0</c:formatCode>
+                <c:ptCount val="4"/>
+                <c:pt idx="0">
+                  <c:v>14.0</c:v>
+                </c:pt>
+                <c:pt idx="1">
+                  <c:v>17.0</c:v>
+                </c:pt>
+                <c:pt idx="2">
+                  <c:v>19.0</c:v>
+                </c:pt>
+                <c:pt idx="3">
+                  <c:v>22.0</c:v>
+                </c:pt>
+              </c:numCache>
+            </c:numRef>
+          </c:val>
+        </c:ser>
+        <c:gapWidth val="80"/>
+        <c:axId val="-2068027336"/>
+        <c:axId val="-2113994440"/>
+      </c:barChart>
+      <c:catAx>
+        <c:axId val="-2068027336"/>
+        <c:scaling>
+          <c:orientation val="minMax"/>
+        </c:scaling>
+        <c:delete val="0"/>
+        <c:axPos val="b"/>
+        <c:majorTickMark val="none"/>
+        <c:minorTickMark val="none"/>
+        <c:tickLblPos val="nextTo"/>
+        <c:spPr>
+          <a:ln>
+            <a:solidFill>
+              <a:schemeClr val="tx1">
+                <a:lumMod val="40000"/>
+                <a:lumOff val="60000"/>
+              </a:schemeClr>
+            </a:solidFill>
+          </a:ln>
+        </c:spPr>
+        <c:crossAx val="-2113994440"/>
+        <c:crosses val="autoZero"/>
+        <c:auto val="1"/>
+        <c:lblAlgn val="ctr"/>
+        <c:lblOffset val="100"/>
+        <c:noMultiLvlLbl val="0"/>
+      </c:catAx>
+      <c:valAx>
+        <c:axId val="-2113994440"/>
+        <c:scaling/>
+        <c:delete val="0"/>
+        <c:axPos val="l"/>
+        <c:majorGridlines>
+          <c:spPr>
+            <a:ln w="9525">
+              <a:solidFill>
+                <a:schemeClr val="tx1">
+                  <a:lumMod val="15000"/>
+                  <a:lumOff val="85000"/>
+                </a:schemeClr>
+              </a:solidFill>
+            </a:ln>
+          </c:spPr>
+        </c:majorGridlines>
+        <c:numFmt formatCode="#,##0" sourceLinked="0"/>
+        <c:majorTickMark val="none"/>
+        <c:minorTickMark val="none"/>
+        <c:tickLblPos val="nextTo"/>
+        <c:spPr>
+          <a:ln>
+            <a:noFill/>
+          </a:ln>
+        </c:spPr>
+        <c:crossAx val="-2068027336"/>
+        <c:crosses val="autoZero"/>
+      </c:valAx>
+    </c:plotArea>
+    <c:legend>
+      <c:legendPos val="b"/>
+      <c:overlay val="0"/>
+      <c:txPr>
+        <a:bodyPr/>
+        <a:lstStyle/>
+        <a:p>
+          <a:pPr>
+            <a:defRPr sz="1200" b="0">
+              <a:solidFill>
+                <a:schemeClr val="tx1">
+                  <a:lumMod val="75000"/>
+                  <a:lumOff val="25000"/>
+                </a:schemeClr>
+              </a:solidFill>
+            </a:defRPr>
+          </a:pPr>
+        </a:p>
+      </c:txPr>
+    </c:legend>
+    <c:dispBlanksAs val="gap"/>
+  </c:chart>
+  <c:txPr>
+    <a:bodyPr/>
+    <a:lstStyle/>
+    <a:p>
+      <a:pPr>
+        <a:defRPr sz="1200" b="0">
+          <a:solidFill>
+            <a:schemeClr val="tx1">
+              <a:lumMod val="75000"/>
+              <a:lumOff val="25000"/>
+            </a:schemeClr>
+          </a:solidFill>
+          <a:latin typeface="+mn-lt"/>
+        </a:defRPr>
+      </a:pPr>
+      <a:endParaRPr lang="en-US"/>
+    </a:p>
+  </c:txPr>
+  <c:externalData r:id="rId1">
+    <c:autoUpdate val="0"/>
+  </c:externalData>
+</c:chartSpace>
+</file>
+
 <file path=ppt/notesMasters/notesMaster1.xml><?xml version="1.0" encoding="utf-8"?>
 <p:notesMaster xmlns:a="http://schemas.openxmlformats.org/drawingml/2006/main" xmlns:r="http://schemas.openxmlformats.org/officeDocument/2006/relationships" xmlns:p="http://schemas.openxmlformats.org/presentationml/2006/main">
   <p:cSld>
@@ -1363,6 +1602,76 @@
 </p:notes>
 </file>
 
+<file path=ppt/notesSlides/notesSlide16.xml><?xml version="1.0" encoding="utf-8"?>
+<p:notes xmlns:a="http://schemas.openxmlformats.org/drawingml/2006/main" xmlns:p="http://schemas.openxmlformats.org/presentationml/2006/main" xmlns:r="http://schemas.openxmlformats.org/officeDocument/2006/relationships">
+  <p:cSld>
+    <p:spTree>
+      <p:nvGrpSpPr>
+        <p:cNvPr id="1" name=""/>
+        <p:cNvGrpSpPr/>
+        <p:nvPr/>
+      </p:nvGrpSpPr>
+      <p:grpSpPr>
+        <a:xfrm>
+          <a:off x="0" y="0"/>
+          <a:ext cx="0" cy="0"/>
+          <a:chOff x="0" y="0"/>
+          <a:chExt cx="0" cy="0"/>
+        </a:xfrm>
+      </p:grpSpPr>
+      <p:sp>
+        <p:nvSpPr>
+          <p:cNvPr id="2" name="Slide Image Placeholder 1"/>
+          <p:cNvSpPr>
+            <a:spLocks noGrp="1"/>
+          </p:cNvSpPr>
+          <p:nvPr>
+            <p:ph type="sldImg" idx="2"/>
+          </p:nvPr>
+        </p:nvSpPr>
+        <p:spPr/>
+      </p:sp>
+      <p:sp>
+        <p:nvSpPr>
+          <p:cNvPr id="3" name="Notes Placeholder 2"/>
+          <p:cNvSpPr>
+            <a:spLocks noGrp="1"/>
+          </p:cNvSpPr>
+          <p:nvPr>
+            <p:ph type="body" idx="3" sz="quarter"/>
+          </p:nvPr>
+        </p:nvSpPr>
+        <p:spPr/>
+        <p:txBody>
+          <a:bodyPr/>
+          <a:lstStyle/>
+          <a:p>
+            <a:r>
+              <a:t>Layout: Fred Chart Wide. A native chart across the content width, for a chart that needs no commentary beside it.</a:t>
+            </a:r>
+          </a:p>
+        </p:txBody>
+      </p:sp>
+      <p:sp>
+        <p:nvSpPr>
+          <p:cNvPr id="4" name="Slide Number Placeholder 3"/>
+          <p:cNvSpPr>
+            <a:spLocks noGrp="1"/>
+          </p:cNvSpPr>
+          <p:nvPr>
+            <p:ph type="sldNum" idx="5" sz="quarter"/>
+          </p:nvPr>
+        </p:nvSpPr>
+        <p:spPr/>
+      </p:sp>
+    </p:spTree>
+  </p:cSld>
+  <p:clrMapOvr>
+    <a:masterClrMapping/>
+  </p:clrMapOvr>
+</p:notes>
+</file>
+
 <file path=ppt/notesSlides/notesSlide2.xml><?xml version="1.0" encoding="utf-8"?>
 <p:notes xmlns:a="http://schemas.openxmlformats.org/drawingml/2006/main" xmlns:r="http://schemas.openxmlformats.org/officeDocument/2006/relationships" xmlns:p="http://schemas.openxmlformats.org/presentationml/2006/main">
   <p:cSld>
@@ -2065,6 +2374,176 @@
     <a:masterClrMapping/>
   </p:clrMapOvr>
 </p:notes>
+</file>
+
+<file path=ppt/slideLayouts/slideLayout1.xml><?xml version="1.0" encoding="utf-8"?>
+<p:sldLayout xmlns:a="http://schemas.openxmlformats.org/drawingml/2006/main" xmlns:r="http://schemas.openxmlformats.org/officeDocument/2006/relationships" xmlns:p="http://schemas.openxmlformats.org/presentationml/2006/main" preserve="1">
+  <p:cSld name="Fred Chart Wide">
+    <p:bg>
+      <p:bgPr>
+        <a:solidFill>
+          <a:schemeClr val="bg1"/>
+        </a:solidFill>
+      </p:bgPr>
+    </p:bg>
+    <p:spTree>
+      <p:nvGrpSpPr>
+        <p:cNvPr id="1" name=""/>
+        <p:cNvGrpSpPr/>
+        <p:nvPr/>
+      </p:nvGrpSpPr>
+      <p:grpSpPr>
+        <a:xfrm>
+          <a:off x="0" y="0"/>
+          <a:ext cx="0" cy="0"/>
+          <a:chOff x="0" y="0"/>
+          <a:chExt cx="0" cy="0"/>
+        </a:xfrm>
+      </p:grpSpPr>
+      <p:sp>
+        <p:nvSpPr>
+          <p:cNvPr id="2" name="title"/>
+          <p:cNvSpPr/>
+          <p:nvPr>
+            <p:ph idx="100" type="title" hasCustomPrompt="1"/>
+          </p:nvPr>
+        </p:nvSpPr>
+        <p:spPr>
+          <a:xfrm>
+            <a:off x="548640" y="411480"/>
+            <a:ext cx="11094415" cy="868680"/>
+          </a:xfrm>
+          <a:prstGeom prst="rect">
+            <a:avLst/>
+          </a:prstGeom>
+          <a:noFill/>
+          <a:ln/>
+        </p:spPr>
+        <p:txBody>
+          <a:bodyPr wrap="square" rtlCol="0"/>
+          <a:lstStyle>
+            <a:lvl1pPr indent="0" marL="0" algn="l">
+              <a:buNone/>
+              <a:defRPr lang="en-US" sz="3200" b="1" dirty="0">
+                <a:solidFill>
+                  <a:schemeClr val="tx1"/>
+                </a:solidFill>
+              </a:defRPr>
+            </a:lvl1pPr>
+          </a:lstStyle>
+          <a:p>
+            <a:pPr indent="0" marL="0">
+              <a:buNone/>
+            </a:pPr>
+            <a:r>
+              <a:rPr lang="en-US" sz="3200" b="1" dirty="0">
+                <a:solidFill>
+                  <a:schemeClr val="tx1"/>
+                </a:solidFill>
+              </a:rPr>
+              <a:t>Slide title</a:t>
+            </a:r>
+            <a:endParaRPr lang="en-US" sz="3200" dirty="0"/>
+          </a:p>
+        </p:txBody>
+      </p:sp>
+      <p:sp>
+        <p:nvSpPr>
+          <p:cNvPr id="3" name="chart"/>
+          <p:cNvSpPr/>
+          <p:nvPr>
+            <p:ph idx="101" type="chart" hasCustomPrompt="1"/>
+          </p:nvPr>
+        </p:nvSpPr>
+        <p:spPr>
+          <a:xfrm>
+            <a:off x="548640" y="1508760"/>
+            <a:ext cx="11094415" cy="4526280"/>
+          </a:xfrm>
+          <a:prstGeom prst="rect">
+            <a:avLst/>
+          </a:prstGeom>
+          <a:noFill/>
+          <a:ln/>
+        </p:spPr>
+        <p:txBody>
+          <a:bodyPr wrap="square" rtlCol="0"/>
+          <a:lstStyle>
+            <a:lvl1pPr indent="0" marL="0">
+              <a:buNone/>
+              <a:defRPr lang="en-US" dirty="0">
+                <a:solidFill>
+                  <a:schemeClr val="tx1"/>
+                </a:solidFill>
+              </a:defRPr>
+            </a:lvl1pPr>
+          </a:lstStyle>
+          <a:p>
+            <a:pPr indent="0" marL="0">
+              <a:buNone/>
+            </a:pPr>
+            <a:r>
+              <a:rPr lang="en-US" dirty="0">
+                <a:solidFill>
+                  <a:schemeClr val="tx1"/>
+                </a:solidFill>
+              </a:rPr>
+              <a:t>Chart</a:t>
+            </a:r>
+            <a:endParaRPr lang="en-US" dirty="0"/>
+          </a:p>
+        </p:txBody>
+      </p:sp>
+      <p:sp>
+        <p:nvSpPr>
+          <p:cNvPr id="25" name="Slide number"/>
+          <p:cNvSpPr txBox="1"/>
+          <p:nvPr/>
+        </p:nvSpPr>
+        <p:spPr>
+          <a:xfrm>
+            <a:off x="10911535" y="6327648"/>
+            <a:ext cx="731520" cy="274320"/>
+          </a:xfrm>
+          <a:prstGeom prst="rect">
+            <a:avLst/>
+          </a:prstGeom>
+          <a:extLst>
+            <a:ext uri="{C572A759-6A51-4108-AA02-DFA0A04FC94B}">
+              <ma14:wrappingTextBoxFlag xmlns:ma14="http://schemas.microsoft.com/office/mac/drawingml/2011/main" val="0"/>
+            </a:ext>
+          </a:extLst>
+        </p:spPr>
+        <p:txBody>
+          <a:bodyPr lIns="0" tIns="0" rIns="0" bIns="0" anchor="b"/>
+          <a:lstStyle>
+            <a:lvl1pPr>
+              <a:defRPr sz="1000">
+                <a:solidFill>
+                  <a:srgbClr val="6A6B6D"/>
+                </a:solidFill>
+                <a:latin typeface="Arial"/>
+                <a:ea typeface="Arial"/>
+                <a:cs typeface="Arial"/>
+              </a:defRPr>
+            </a:lvl1pPr>
+          </a:lstStyle>
+          <a:p>
+            <a:pPr algn="r"/>
+            <a:fld id="{F7021451-1387-4CA6-816F-3879F97B5CBC}" type="slidenum">
+              <a:rPr b="0" lang="en-US"/>
+              <a:t>1011</a:t>
+            </a:fld>
+            <a:endParaRPr lang="en-US"/>
+          </a:p>
+        </p:txBody>
+      </p:sp>
+    </p:spTree>
+  </p:cSld>
+  <p:clrMapOvr>
+    <a:masterClrMapping/>
+  </p:clrMapOvr>
+</p:sldLayout>
 </file>
 
 <file path=ppt/slideLayouts/slideLayout10.xml><?xml version="1.0" encoding="utf-8"?>
@@ -6524,6 +7003,7 @@
     <p:sldLayoutId id="2147483657" r:id="rId9"/>
     <p:sldLayoutId id="2147483658" r:id="rId10"/>
     <p:sldLayoutId id="2147483659" r:id="rId11"/>
+    <p:sldLayoutId id="2147483665" r:id="rId1"/>
     <p:sldLayoutId id="2147483660" r:id="rId12"/>
     <p:sldLayoutId id="2147483661" r:id="rId13"/>
     <p:sldLayoutId id="2147483662" r:id="rId14"/>
@@ -8934,6 +9414,65 @@
 </p:sld>
 </file>
 
+<file path=ppt/slides/slide16.xml><?xml version="1.0" encoding="utf-8"?>
+<p:sld xmlns:a="http://schemas.openxmlformats.org/drawingml/2006/main" xmlns:p="http://schemas.openxmlformats.org/presentationml/2006/main" xmlns:r="http://schemas.openxmlformats.org/officeDocument/2006/relationships">
+  <p:cSld>
+    <p:spTree>
+      <p:nvGrpSpPr>
+        <p:cNvPr id="1" name=""/>
+        <p:cNvGrpSpPr/>
+        <p:nvPr/>
+      </p:nvGrpSpPr>
+      <p:grpSpPr/>
+      <p:sp>
+        <p:nvSpPr>
+          <p:cNvPr id="2" name="Title 1"/>
+          <p:cNvSpPr>
+            <a:spLocks noGrp="1"/>
+          </p:cNvSpPr>
+          <p:nvPr>
+            <p:ph type="title" idx="100"/>
+          </p:nvPr>
+        </p:nvSpPr>
+        <p:spPr/>
+        <p:txBody>
+          <a:bodyPr/>
+          <a:lstStyle/>
+          <a:p>
+            <a:r>
+              <a:t>One chart across the slide</a:t>
+            </a:r>
+          </a:p>
+        </p:txBody>
+      </p:sp>
+      <p:graphicFrame>
+        <p:nvGraphicFramePr>
+          <p:cNvPr id="4" name="Chart 3"/>
+          <p:cNvGraphicFramePr>
+            <a:graphicFrameLocks noGrp="1"/>
+          </p:cNvGraphicFramePr>
+          <p:nvPr>
+            <p:ph type="chart" idx="101"/>
+          </p:nvPr>
+        </p:nvGraphicFramePr>
+        <p:xfrm>
+          <a:off x="548640" y="1508760"/>
+          <a:ext cx="11094415" cy="4526280"/>
+        </p:xfrm>
+        <a:graphic>
+          <a:graphicData uri="http://schemas.openxmlformats.org/drawingml/2006/chart">
+            <c:chart xmlns:c="http://schemas.openxmlformats.org/drawingml/2006/chart" r:id="rId2"/>
+          </a:graphicData>
+        </a:graphic>
+      </p:graphicFrame>
+    </p:spTree>
+  </p:cSld>
+  <p:clrMapOvr>
+    <a:masterClrMapping/>
+  </p:clrMapOvr>
+</p:sld>
+</file>
+
 <file path=ppt/slides/slide2.xml><?xml version="1.0" encoding="utf-8"?>
 <p:sld xmlns:a="http://schemas.openxmlformats.org/drawingml/2006/main" xmlns:r="http://schemas.openxmlformats.org/officeDocument/2006/relationships" xmlns:p="http://schemas.openxmlformats.org/presentationml/2006/main">
   <p:cSld name="Slide 2">

</xml_diff>

<commit_message>
feat(#2679): turn the built-in template's table slide into a data table to fill
The example table held real layout text and no header flag, so the analysis
kept it as a drawing and the default configuration offered no table.
</commit_message>
<xml_diff>
--- a/libs/capabilities/fred-capability-ppt-filler/fred_capability_ppt_filler/builder/assets/fred_template.pptx
+++ b/libs/capabilities/fred-capability-ppt-filler/fred_capability_ppt_filler/builder/assets/fred_template.pptx
@@ -1208,7 +1208,7 @@
           <a:p>
             <a:r>
               <a:rPr lang="en-US" dirty="0"/>
-              <a:t>Layout: Fred Table. Up to ~8 rows and 5 columns; split larger tables across slides.</a:t>
+              <a:t>Layout: Fred Table. Header row and up to about 10 short rows, 5 columns; longer tables continue on a second slide.</a:t>
             </a:r>
             <a:endParaRPr lang="en-US" dirty="0"/>
           </a:p>
@@ -7479,7 +7479,7 @@
           <a:p>
             <a:r>
               <a:rPr lang="en-US"/>
-              <a:t>Layout catalogue</a:t>
+              <a:t>Compare options side by side</a:t>
             </a:r>
             <a:endParaRPr lang="en-US"/>
           </a:p>
@@ -7506,11 +7506,15 @@
         <a:graphic>
           <a:graphicData uri="http://schemas.openxmlformats.org/drawingml/2006/table">
             <a:tbl>
-              <a:tblPr/>
+              <a:tblPr firstRow="1" bandRow="1">
+                <a:tableStyleId>{5C22544A-7EE6-4342-B048-85BDC9FD1C3A}</a:tableStyleId>
+              </a:tblPr>
               <a:tblGrid>
                 <a:gridCol w="2926080"/>
-                <a:gridCol w="3566160"/>
-                <a:gridCol w="4602175"/>
+                <a:gridCol w="2042084"/>
+                <a:gridCol w="2042084"/>
+                <a:gridCol w="2042084"/>
+                <a:gridCol w="2042083"/>
               </a:tblGrid>
               <a:tr h="502920">
                 <a:tc>
@@ -7518,1386 +7522,590 @@
                     <a:bodyPr/>
                     <a:lstStyle/>
                     <a:p>
-                      <a:pPr indent="0" marL="0">
-                        <a:buNone/>
-                      </a:pPr>
                       <a:r>
-                        <a:rPr lang="en-US" sz="1400" b="1" dirty="0">
-                          <a:solidFill>
-                            <a:schemeClr val="bg1"/>
-                          </a:solidFill>
-                          <a:latin typeface="Arial" pitchFamily="34" charset="0"/>
-                          <a:ea typeface="Arial" pitchFamily="34" charset="-122"/>
-                          <a:cs typeface="Arial" pitchFamily="34" charset="-120"/>
-                        </a:rPr>
-                        <a:t>Layout</a:t>
+                        <a:rPr lang="en-US" sz="1400" dirty="0" b="1"/>
+                        <a:t>Criterion</a:t>
                       </a:r>
-                      <a:endParaRPr lang="en-US" sz="1400" dirty="0">
-                        <a:latin typeface="Arial" charset="0"/>
-                        <a:ea typeface="Arial" charset="0"/>
-                        <a:cs typeface="Arial" charset="0"/>
-                      </a:endParaRPr>
+                      <a:endParaRPr lang="en-US" sz="1400" dirty="0" b="1"/>
                     </a:p>
                   </a:txBody>
-                  <a:tcPr marL="137160" marR="137160" marT="73152" marB="73152" anchor="ctr">
-                    <a:lnL w="9525" cap="flat" cmpd="sng" algn="ctr">
-                      <a:solidFill>
-                        <a:srgbClr val="DCDDE0"/>
-                      </a:solidFill>
-                      <a:prstDash val="solid"/>
-                      <a:round/>
-                      <a:headEnd type="none" w="med" len="med"/>
-                      <a:tailEnd type="none" w="med" len="med"/>
-                    </a:lnL>
-                    <a:lnR w="9525" cap="flat" cmpd="sng" algn="ctr">
-                      <a:solidFill>
-                        <a:srgbClr val="DCDDE0"/>
-                      </a:solidFill>
-                      <a:prstDash val="solid"/>
-                      <a:round/>
-                      <a:headEnd type="none" w="med" len="med"/>
-                      <a:tailEnd type="none" w="med" len="med"/>
-                    </a:lnR>
-                    <a:lnT w="9525" cap="flat" cmpd="sng" algn="ctr">
-                      <a:solidFill>
-                        <a:srgbClr val="DCDDE0"/>
-                      </a:solidFill>
-                      <a:prstDash val="solid"/>
-                      <a:round/>
-                      <a:headEnd type="none" w="med" len="med"/>
-                      <a:tailEnd type="none" w="med" len="med"/>
-                    </a:lnT>
-                    <a:lnB w="9525" cap="flat" cmpd="sng" algn="ctr">
-                      <a:solidFill>
-                        <a:srgbClr val="DCDDE0"/>
-                      </a:solidFill>
-                      <a:prstDash val="solid"/>
-                      <a:round/>
-                      <a:headEnd type="none" w="med" len="med"/>
-                      <a:tailEnd type="none" w="med" len="med"/>
-                    </a:lnB>
-                    <a:solidFill>
-                      <a:schemeClr val="accent1"/>
-                    </a:solidFill>
-                  </a:tcPr>
+                  <a:tcPr marL="137160" marR="137160" marT="73152" marB="73152" anchor="ctr"/>
                 </a:tc>
                 <a:tc>
                   <a:txBody>
                     <a:bodyPr/>
                     <a:lstStyle/>
                     <a:p>
-                      <a:pPr indent="0" marL="0">
-                        <a:buNone/>
-                      </a:pPr>
                       <a:r>
-                        <a:rPr lang="en-US" sz="1400" b="1" dirty="0">
-                          <a:solidFill>
-                            <a:schemeClr val="bg1"/>
-                          </a:solidFill>
-                          <a:latin typeface="Arial" pitchFamily="34" charset="0"/>
-                          <a:ea typeface="Arial" pitchFamily="34" charset="-122"/>
-                          <a:cs typeface="Arial" pitchFamily="34" charset="-120"/>
-                        </a:rPr>
-                        <a:t>Use it for</a:t>
+                        <a:rPr lang="en-US" sz="1400" dirty="0" b="1"/>
+                        <a:t>Option A</a:t>
                       </a:r>
-                      <a:endParaRPr lang="en-US" sz="1400" dirty="0">
-                        <a:latin typeface="Arial" charset="0"/>
-                        <a:ea typeface="Arial" charset="0"/>
-                        <a:cs typeface="Arial" charset="0"/>
-                      </a:endParaRPr>
+                      <a:endParaRPr lang="en-US" sz="1400" dirty="0" b="1"/>
                     </a:p>
                   </a:txBody>
-                  <a:tcPr marL="137160" marR="137160" marT="73152" marB="73152" anchor="ctr">
-                    <a:lnL w="9525" cap="flat" cmpd="sng" algn="ctr">
-                      <a:solidFill>
-                        <a:srgbClr val="DCDDE0"/>
-                      </a:solidFill>
-                      <a:prstDash val="solid"/>
-                      <a:round/>
-                      <a:headEnd type="none" w="med" len="med"/>
-                      <a:tailEnd type="none" w="med" len="med"/>
-                    </a:lnL>
-                    <a:lnR w="9525" cap="flat" cmpd="sng" algn="ctr">
-                      <a:solidFill>
-                        <a:srgbClr val="DCDDE0"/>
-                      </a:solidFill>
-                      <a:prstDash val="solid"/>
-                      <a:round/>
-                      <a:headEnd type="none" w="med" len="med"/>
-                      <a:tailEnd type="none" w="med" len="med"/>
-                    </a:lnR>
-                    <a:lnT w="9525" cap="flat" cmpd="sng" algn="ctr">
-                      <a:solidFill>
-                        <a:srgbClr val="DCDDE0"/>
-                      </a:solidFill>
-                      <a:prstDash val="solid"/>
-                      <a:round/>
-                      <a:headEnd type="none" w="med" len="med"/>
-                      <a:tailEnd type="none" w="med" len="med"/>
-                    </a:lnT>
-                    <a:lnB w="9525" cap="flat" cmpd="sng" algn="ctr">
-                      <a:solidFill>
-                        <a:srgbClr val="DCDDE0"/>
-                      </a:solidFill>
-                      <a:prstDash val="solid"/>
-                      <a:round/>
-                      <a:headEnd type="none" w="med" len="med"/>
-                      <a:tailEnd type="none" w="med" len="med"/>
-                    </a:lnB>
-                    <a:solidFill>
-                      <a:schemeClr val="accent1"/>
-                    </a:solidFill>
-                  </a:tcPr>
+                  <a:tcPr marL="137160" marR="137160" marT="73152" marB="73152" anchor="ctr"/>
                 </a:tc>
                 <a:tc>
                   <a:txBody>
                     <a:bodyPr/>
                     <a:lstStyle/>
                     <a:p>
-                      <a:pPr indent="0" marL="0">
-                        <a:buNone/>
-                      </a:pPr>
                       <a:r>
-                        <a:rPr lang="en-US" sz="1400" b="1" dirty="0">
-                          <a:solidFill>
-                            <a:schemeClr val="bg1"/>
-                          </a:solidFill>
-                          <a:latin typeface="Arial" pitchFamily="34" charset="0"/>
-                          <a:ea typeface="Arial" pitchFamily="34" charset="-122"/>
-                          <a:cs typeface="Arial" pitchFamily="34" charset="-120"/>
-                        </a:rPr>
-                        <a:t>Placeholders</a:t>
+                        <a:rPr lang="en-US" sz="1400" dirty="0" b="1"/>
+                        <a:t>Option B</a:t>
                       </a:r>
-                      <a:endParaRPr lang="en-US" sz="1400" dirty="0">
-                        <a:latin typeface="Arial" charset="0"/>
-                        <a:ea typeface="Arial" charset="0"/>
-                        <a:cs typeface="Arial" charset="0"/>
-                      </a:endParaRPr>
+                      <a:endParaRPr lang="en-US" sz="1400" dirty="0" b="1"/>
                     </a:p>
                   </a:txBody>
-                  <a:tcPr marL="137160" marR="137160" marT="73152" marB="73152" anchor="ctr">
-                    <a:lnL w="9525" cap="flat" cmpd="sng" algn="ctr">
-                      <a:solidFill>
-                        <a:srgbClr val="DCDDE0"/>
-                      </a:solidFill>
-                      <a:prstDash val="solid"/>
-                      <a:round/>
-                      <a:headEnd type="none" w="med" len="med"/>
-                      <a:tailEnd type="none" w="med" len="med"/>
-                    </a:lnL>
-                    <a:lnR w="9525" cap="flat" cmpd="sng" algn="ctr">
-                      <a:solidFill>
-                        <a:srgbClr val="DCDDE0"/>
-                      </a:solidFill>
-                      <a:prstDash val="solid"/>
-                      <a:round/>
-                      <a:headEnd type="none" w="med" len="med"/>
-                      <a:tailEnd type="none" w="med" len="med"/>
-                    </a:lnR>
-                    <a:lnT w="9525" cap="flat" cmpd="sng" algn="ctr">
-                      <a:solidFill>
-                        <a:srgbClr val="DCDDE0"/>
-                      </a:solidFill>
-                      <a:prstDash val="solid"/>
-                      <a:round/>
-                      <a:headEnd type="none" w="med" len="med"/>
-                      <a:tailEnd type="none" w="med" len="med"/>
-                    </a:lnT>
-                    <a:lnB w="9525" cap="flat" cmpd="sng" algn="ctr">
-                      <a:solidFill>
-                        <a:srgbClr val="DCDDE0"/>
-                      </a:solidFill>
-                      <a:prstDash val="solid"/>
-                      <a:round/>
-                      <a:headEnd type="none" w="med" len="med"/>
-                      <a:tailEnd type="none" w="med" len="med"/>
-                    </a:lnB>
-                    <a:solidFill>
-                      <a:schemeClr val="accent1"/>
-                    </a:solidFill>
-                  </a:tcPr>
-                </a:tc>
-              </a:tr>
-              <a:tr h="502920">
-                <a:tc>
-                  <a:txBody>
-                    <a:bodyPr/>
-                    <a:lstStyle/>
-                    <a:p>
-                      <a:pPr indent="0" marL="0">
-                        <a:buNone/>
-                      </a:pPr>
-                      <a:r>
-                        <a:rPr lang="en-US" sz="1400" dirty="0">
-                          <a:solidFill>
-                            <a:schemeClr val="tx1"/>
-                          </a:solidFill>
-                          <a:latin typeface="Arial" pitchFamily="34" charset="0"/>
-                          <a:ea typeface="Arial" pitchFamily="34" charset="-122"/>
-                          <a:cs typeface="Arial" pitchFamily="34" charset="-120"/>
-                        </a:rPr>
-                        <a:t>Fred Title</a:t>
-                      </a:r>
-                      <a:endParaRPr lang="en-US" sz="1400" dirty="0">
-                        <a:latin typeface="Arial" charset="0"/>
-                        <a:ea typeface="Arial" charset="0"/>
-                        <a:cs typeface="Arial" charset="0"/>
-                      </a:endParaRPr>
-                    </a:p>
-                  </a:txBody>
-                  <a:tcPr marL="137160" marR="137160" marT="73152" marB="73152" anchor="ctr">
-                    <a:lnL w="9525" cap="flat" cmpd="sng" algn="ctr">
-                      <a:solidFill>
-                        <a:srgbClr val="DCDDE0"/>
-                      </a:solidFill>
-                      <a:prstDash val="solid"/>
-                      <a:round/>
-                      <a:headEnd type="none" w="med" len="med"/>
-                      <a:tailEnd type="none" w="med" len="med"/>
-                    </a:lnL>
-                    <a:lnR w="9525" cap="flat" cmpd="sng" algn="ctr">
-                      <a:solidFill>
-                        <a:srgbClr val="DCDDE0"/>
-                      </a:solidFill>
-                      <a:prstDash val="solid"/>
-                      <a:round/>
-                      <a:headEnd type="none" w="med" len="med"/>
-                      <a:tailEnd type="none" w="med" len="med"/>
-                    </a:lnR>
-                    <a:lnT w="9525" cap="flat" cmpd="sng" algn="ctr">
-                      <a:solidFill>
-                        <a:srgbClr val="DCDDE0"/>
-                      </a:solidFill>
-                      <a:prstDash val="solid"/>
-                      <a:round/>
-                      <a:headEnd type="none" w="med" len="med"/>
-                      <a:tailEnd type="none" w="med" len="med"/>
-                    </a:lnT>
-                    <a:lnB w="9525" cap="flat" cmpd="sng" algn="ctr">
-                      <a:solidFill>
-                        <a:srgbClr val="DCDDE0"/>
-                      </a:solidFill>
-                      <a:prstDash val="solid"/>
-                      <a:round/>
-                      <a:headEnd type="none" w="med" len="med"/>
-                      <a:tailEnd type="none" w="med" len="med"/>
-                    </a:lnB>
-                  </a:tcPr>
+                  <a:tcPr marL="137160" marR="137160" marT="73152" marB="73152" anchor="ctr"/>
                 </a:tc>
                 <a:tc>
                   <a:txBody>
                     <a:bodyPr/>
                     <a:lstStyle/>
                     <a:p>
-                      <a:pPr indent="0" marL="0">
-                        <a:buNone/>
-                      </a:pPr>
                       <a:r>
-                        <a:rPr lang="en-US" sz="1400" dirty="0">
-                          <a:solidFill>
-                            <a:schemeClr val="tx1"/>
-                          </a:solidFill>
-                          <a:latin typeface="Arial" pitchFamily="34" charset="0"/>
-                          <a:ea typeface="Arial" pitchFamily="34" charset="-122"/>
-                          <a:cs typeface="Arial" pitchFamily="34" charset="-120"/>
-                        </a:rPr>
-                        <a:t>Opening slide</a:t>
+                        <a:rPr lang="en-US" sz="1400" dirty="0" b="1"/>
+                        <a:t>Option C</a:t>
                       </a:r>
-                      <a:endParaRPr lang="en-US" sz="1400" dirty="0">
-                        <a:latin typeface="Arial" charset="0"/>
-                        <a:ea typeface="Arial" charset="0"/>
-                        <a:cs typeface="Arial" charset="0"/>
-                      </a:endParaRPr>
+                      <a:endParaRPr lang="en-US" sz="1400" dirty="0" b="1"/>
                     </a:p>
                   </a:txBody>
-                  <a:tcPr marL="137160" marR="137160" marT="73152" marB="73152" anchor="ctr">
-                    <a:lnL w="9525" cap="flat" cmpd="sng" algn="ctr">
-                      <a:solidFill>
-                        <a:srgbClr val="DCDDE0"/>
-                      </a:solidFill>
-                      <a:prstDash val="solid"/>
-                      <a:round/>
-                      <a:headEnd type="none" w="med" len="med"/>
-                      <a:tailEnd type="none" w="med" len="med"/>
-                    </a:lnL>
-                    <a:lnR w="9525" cap="flat" cmpd="sng" algn="ctr">
-                      <a:solidFill>
-                        <a:srgbClr val="DCDDE0"/>
-                      </a:solidFill>
-                      <a:prstDash val="solid"/>
-                      <a:round/>
-                      <a:headEnd type="none" w="med" len="med"/>
-                      <a:tailEnd type="none" w="med" len="med"/>
-                    </a:lnR>
-                    <a:lnT w="9525" cap="flat" cmpd="sng" algn="ctr">
-                      <a:solidFill>
-                        <a:srgbClr val="DCDDE0"/>
-                      </a:solidFill>
-                      <a:prstDash val="solid"/>
-                      <a:round/>
-                      <a:headEnd type="none" w="med" len="med"/>
-                      <a:tailEnd type="none" w="med" len="med"/>
-                    </a:lnT>
-                    <a:lnB w="9525" cap="flat" cmpd="sng" algn="ctr">
-                      <a:solidFill>
-                        <a:srgbClr val="DCDDE0"/>
-                      </a:solidFill>
-                      <a:prstDash val="solid"/>
-                      <a:round/>
-                      <a:headEnd type="none" w="med" len="med"/>
-                      <a:tailEnd type="none" w="med" len="med"/>
-                    </a:lnB>
-                  </a:tcPr>
+                  <a:tcPr marL="137160" marR="137160" marT="73152" marB="73152" anchor="ctr"/>
                 </a:tc>
                 <a:tc>
                   <a:txBody>
                     <a:bodyPr/>
                     <a:lstStyle/>
                     <a:p>
-                      <a:pPr indent="0" marL="0">
-                        <a:buNone/>
-                      </a:pPr>
                       <a:r>
-                        <a:rPr lang="en-US" sz="1400" dirty="0">
-                          <a:solidFill>
-                            <a:schemeClr val="tx1"/>
-                          </a:solidFill>
-                          <a:latin typeface="Arial" pitchFamily="34" charset="0"/>
-                          <a:ea typeface="Arial" pitchFamily="34" charset="-122"/>
-                          <a:cs typeface="Arial" pitchFamily="34" charset="-120"/>
-                        </a:rPr>
-                        <a:t>title, subtitle, meta</a:t>
+                        <a:rPr lang="en-US" sz="1400" dirty="0" b="1"/>
+                        <a:t>Option D</a:t>
                       </a:r>
-                      <a:endParaRPr lang="en-US" sz="1400" dirty="0">
-                        <a:latin typeface="Arial" charset="0"/>
-                        <a:ea typeface="Arial" charset="0"/>
-                        <a:cs typeface="Arial" charset="0"/>
-                      </a:endParaRPr>
+                      <a:endParaRPr lang="en-US" sz="1400" dirty="0" b="1"/>
                     </a:p>
                   </a:txBody>
-                  <a:tcPr marL="137160" marR="137160" marT="73152" marB="73152" anchor="ctr">
-                    <a:lnL w="9525" cap="flat" cmpd="sng" algn="ctr">
-                      <a:solidFill>
-                        <a:srgbClr val="DCDDE0"/>
-                      </a:solidFill>
-                      <a:prstDash val="solid"/>
-                      <a:round/>
-                      <a:headEnd type="none" w="med" len="med"/>
-                      <a:tailEnd type="none" w="med" len="med"/>
-                    </a:lnL>
-                    <a:lnR w="9525" cap="flat" cmpd="sng" algn="ctr">
-                      <a:solidFill>
-                        <a:srgbClr val="DCDDE0"/>
-                      </a:solidFill>
-                      <a:prstDash val="solid"/>
-                      <a:round/>
-                      <a:headEnd type="none" w="med" len="med"/>
-                      <a:tailEnd type="none" w="med" len="med"/>
-                    </a:lnR>
-                    <a:lnT w="9525" cap="flat" cmpd="sng" algn="ctr">
-                      <a:solidFill>
-                        <a:srgbClr val="DCDDE0"/>
-                      </a:solidFill>
-                      <a:prstDash val="solid"/>
-                      <a:round/>
-                      <a:headEnd type="none" w="med" len="med"/>
-                      <a:tailEnd type="none" w="med" len="med"/>
-                    </a:lnT>
-                    <a:lnB w="9525" cap="flat" cmpd="sng" algn="ctr">
-                      <a:solidFill>
-                        <a:srgbClr val="DCDDE0"/>
-                      </a:solidFill>
-                      <a:prstDash val="solid"/>
-                      <a:round/>
-                      <a:headEnd type="none" w="med" len="med"/>
-                      <a:tailEnd type="none" w="med" len="med"/>
-                    </a:lnB>
-                  </a:tcPr>
+                  <a:tcPr marL="137160" marR="137160" marT="73152" marB="73152" anchor="ctr"/>
                 </a:tc>
               </a:tr>
-              <a:tr h="502920">
+              <a:tr h="402336">
                 <a:tc>
                   <a:txBody>
                     <a:bodyPr/>
                     <a:lstStyle/>
                     <a:p>
-                      <a:pPr indent="0" marL="0">
-                        <a:buNone/>
-                      </a:pPr>
-                      <a:r>
-                        <a:rPr lang="en-US" sz="1400" dirty="0">
-                          <a:solidFill>
-                            <a:schemeClr val="tx1"/>
-                          </a:solidFill>
-                          <a:latin typeface="Arial" pitchFamily="34" charset="0"/>
-                          <a:ea typeface="Arial" pitchFamily="34" charset="-122"/>
-                          <a:cs typeface="Arial" pitchFamily="34" charset="-120"/>
-                        </a:rPr>
-                        <a:t>Fred Section</a:t>
-                      </a:r>
-                      <a:endParaRPr lang="en-US" sz="1400" dirty="0">
-                        <a:latin typeface="Arial" charset="0"/>
-                        <a:ea typeface="Arial" charset="0"/>
-                        <a:cs typeface="Arial" charset="0"/>
-                      </a:endParaRPr>
+                      <a:endParaRPr lang="en-US" sz="1400" dirty="0"/>
                     </a:p>
                   </a:txBody>
-                  <a:tcPr marL="137160" marR="137160" marT="73152" marB="73152" anchor="ctr">
-                    <a:lnL w="9525" cap="flat" cmpd="sng" algn="ctr">
-                      <a:solidFill>
-                        <a:srgbClr val="DCDDE0"/>
-                      </a:solidFill>
-                      <a:prstDash val="solid"/>
-                      <a:round/>
-                      <a:headEnd type="none" w="med" len="med"/>
-                      <a:tailEnd type="none" w="med" len="med"/>
-                    </a:lnL>
-                    <a:lnR w="9525" cap="flat" cmpd="sng" algn="ctr">
-                      <a:solidFill>
-                        <a:srgbClr val="DCDDE0"/>
-                      </a:solidFill>
-                      <a:prstDash val="solid"/>
-                      <a:round/>
-                      <a:headEnd type="none" w="med" len="med"/>
-                      <a:tailEnd type="none" w="med" len="med"/>
-                    </a:lnR>
-                    <a:lnT w="9525" cap="flat" cmpd="sng" algn="ctr">
-                      <a:solidFill>
-                        <a:srgbClr val="DCDDE0"/>
-                      </a:solidFill>
-                      <a:prstDash val="solid"/>
-                      <a:round/>
-                      <a:headEnd type="none" w="med" len="med"/>
-                      <a:tailEnd type="none" w="med" len="med"/>
-                    </a:lnT>
-                    <a:lnB w="9525" cap="flat" cmpd="sng" algn="ctr">
-                      <a:solidFill>
-                        <a:srgbClr val="DCDDE0"/>
-                      </a:solidFill>
-                      <a:prstDash val="solid"/>
-                      <a:round/>
-                      <a:headEnd type="none" w="med" len="med"/>
-                      <a:tailEnd type="none" w="med" len="med"/>
-                    </a:lnB>
-                  </a:tcPr>
+                  <a:tcPr marL="137160" marR="137160" marT="73152" marB="73152" anchor="ctr"/>
                 </a:tc>
                 <a:tc>
                   <a:txBody>
                     <a:bodyPr/>
                     <a:lstStyle/>
                     <a:p>
-                      <a:pPr indent="0" marL="0">
-                        <a:buNone/>
-                      </a:pPr>
-                      <a:r>
-                        <a:rPr lang="en-US" sz="1400" dirty="0">
-                          <a:solidFill>
-                            <a:schemeClr val="tx1"/>
-                          </a:solidFill>
-                          <a:latin typeface="Arial" pitchFamily="34" charset="0"/>
-                          <a:ea typeface="Arial" pitchFamily="34" charset="-122"/>
-                          <a:cs typeface="Arial" pitchFamily="34" charset="-120"/>
-                        </a:rPr>
-                        <a:t>Dividing a long deck</a:t>
-                      </a:r>
-                      <a:endParaRPr lang="en-US" sz="1400" dirty="0">
-                        <a:latin typeface="Arial" charset="0"/>
-                        <a:ea typeface="Arial" charset="0"/>
-                        <a:cs typeface="Arial" charset="0"/>
-                      </a:endParaRPr>
+                      <a:endParaRPr lang="en-US" sz="1400" dirty="0"/>
                     </a:p>
                   </a:txBody>
-                  <a:tcPr marL="137160" marR="137160" marT="73152" marB="73152" anchor="ctr">
-                    <a:lnL w="9525" cap="flat" cmpd="sng" algn="ctr">
-                      <a:solidFill>
-                        <a:srgbClr val="DCDDE0"/>
-                      </a:solidFill>
-                      <a:prstDash val="solid"/>
-                      <a:round/>
-                      <a:headEnd type="none" w="med" len="med"/>
-                      <a:tailEnd type="none" w="med" len="med"/>
-                    </a:lnL>
-                    <a:lnR w="9525" cap="flat" cmpd="sng" algn="ctr">
-                      <a:solidFill>
-                        <a:srgbClr val="DCDDE0"/>
-                      </a:solidFill>
-                      <a:prstDash val="solid"/>
-                      <a:round/>
-                      <a:headEnd type="none" w="med" len="med"/>
-                      <a:tailEnd type="none" w="med" len="med"/>
-                    </a:lnR>
-                    <a:lnT w="9525" cap="flat" cmpd="sng" algn="ctr">
-                      <a:solidFill>
-                        <a:srgbClr val="DCDDE0"/>
-                      </a:solidFill>
-                      <a:prstDash val="solid"/>
-                      <a:round/>
-                      <a:headEnd type="none" w="med" len="med"/>
-                      <a:tailEnd type="none" w="med" len="med"/>
-                    </a:lnT>
-                    <a:lnB w="9525" cap="flat" cmpd="sng" algn="ctr">
-                      <a:solidFill>
-                        <a:srgbClr val="DCDDE0"/>
-                      </a:solidFill>
-                      <a:prstDash val="solid"/>
-                      <a:round/>
-                      <a:headEnd type="none" w="med" len="med"/>
-                      <a:tailEnd type="none" w="med" len="med"/>
-                    </a:lnB>
-                  </a:tcPr>
+                  <a:tcPr marL="137160" marR="137160" marT="73152" marB="73152" anchor="ctr"/>
                 </a:tc>
                 <a:tc>
                   <a:txBody>
                     <a:bodyPr/>
                     <a:lstStyle/>
                     <a:p>
-                      <a:pPr indent="0" marL="0">
-                        <a:buNone/>
-                      </a:pPr>
-                      <a:r>
-                        <a:rPr lang="en-US" sz="1400" dirty="0">
-                          <a:solidFill>
-                            <a:schemeClr val="tx1"/>
-                          </a:solidFill>
-                          <a:latin typeface="Arial" pitchFamily="34" charset="0"/>
-                          <a:ea typeface="Arial" pitchFamily="34" charset="-122"/>
-                          <a:cs typeface="Arial" pitchFamily="34" charset="-120"/>
-                        </a:rPr>
-                        <a:t>section_number, title, subtitle</a:t>
-                      </a:r>
-                      <a:endParaRPr lang="en-US" sz="1400" dirty="0">
-                        <a:latin typeface="Arial" charset="0"/>
-                        <a:ea typeface="Arial" charset="0"/>
-                        <a:cs typeface="Arial" charset="0"/>
-                      </a:endParaRPr>
+                      <a:endParaRPr lang="en-US" sz="1400" dirty="0"/>
                     </a:p>
                   </a:txBody>
-                  <a:tcPr marL="137160" marR="137160" marT="73152" marB="73152" anchor="ctr">
-                    <a:lnL w="9525" cap="flat" cmpd="sng" algn="ctr">
-                      <a:solidFill>
-                        <a:srgbClr val="DCDDE0"/>
-                      </a:solidFill>
-                      <a:prstDash val="solid"/>
-                      <a:round/>
-                      <a:headEnd type="none" w="med" len="med"/>
-                      <a:tailEnd type="none" w="med" len="med"/>
-                    </a:lnL>
-                    <a:lnR w="9525" cap="flat" cmpd="sng" algn="ctr">
-                      <a:solidFill>
-                        <a:srgbClr val="DCDDE0"/>
-                      </a:solidFill>
-                      <a:prstDash val="solid"/>
-                      <a:round/>
-                      <a:headEnd type="none" w="med" len="med"/>
-                      <a:tailEnd type="none" w="med" len="med"/>
-                    </a:lnR>
-                    <a:lnT w="9525" cap="flat" cmpd="sng" algn="ctr">
-                      <a:solidFill>
-                        <a:srgbClr val="DCDDE0"/>
-                      </a:solidFill>
-                      <a:prstDash val="solid"/>
-                      <a:round/>
-                      <a:headEnd type="none" w="med" len="med"/>
-                      <a:tailEnd type="none" w="med" len="med"/>
-                    </a:lnT>
-                    <a:lnB w="9525" cap="flat" cmpd="sng" algn="ctr">
-                      <a:solidFill>
-                        <a:srgbClr val="DCDDE0"/>
-                      </a:solidFill>
-                      <a:prstDash val="solid"/>
-                      <a:round/>
-                      <a:headEnd type="none" w="med" len="med"/>
-                      <a:tailEnd type="none" w="med" len="med"/>
-                    </a:lnB>
-                  </a:tcPr>
-                </a:tc>
-              </a:tr>
-              <a:tr h="502920">
-                <a:tc>
-                  <a:txBody>
-                    <a:bodyPr/>
-                    <a:lstStyle/>
-                    <a:p>
-                      <a:pPr indent="0" marL="0">
-                        <a:buNone/>
-                      </a:pPr>
-                      <a:r>
-                        <a:rPr lang="en-US" sz="1400" dirty="0">
-                          <a:solidFill>
-                            <a:schemeClr val="tx1"/>
-                          </a:solidFill>
-                          <a:latin typeface="Arial" pitchFamily="34" charset="0"/>
-                          <a:ea typeface="Arial" pitchFamily="34" charset="-122"/>
-                          <a:cs typeface="Arial" pitchFamily="34" charset="-120"/>
-                        </a:rPr>
-                        <a:t>Fred Key Figures</a:t>
-                      </a:r>
-                      <a:endParaRPr lang="en-US" sz="1400" dirty="0">
-                        <a:latin typeface="Arial" charset="0"/>
-                        <a:ea typeface="Arial" charset="0"/>
-                        <a:cs typeface="Arial" charset="0"/>
-                      </a:endParaRPr>
-                    </a:p>
-                  </a:txBody>
-                  <a:tcPr marL="137160" marR="137160" marT="73152" marB="73152" anchor="ctr">
-                    <a:lnL w="9525" cap="flat" cmpd="sng" algn="ctr">
-                      <a:solidFill>
-                        <a:srgbClr val="DCDDE0"/>
-                      </a:solidFill>
-                      <a:prstDash val="solid"/>
-                      <a:round/>
-                      <a:headEnd type="none" w="med" len="med"/>
-                      <a:tailEnd type="none" w="med" len="med"/>
-                    </a:lnL>
-                    <a:lnR w="9525" cap="flat" cmpd="sng" algn="ctr">
-                      <a:solidFill>
-                        <a:srgbClr val="DCDDE0"/>
-                      </a:solidFill>
-                      <a:prstDash val="solid"/>
-                      <a:round/>
-                      <a:headEnd type="none" w="med" len="med"/>
-                      <a:tailEnd type="none" w="med" len="med"/>
-                    </a:lnR>
-                    <a:lnT w="9525" cap="flat" cmpd="sng" algn="ctr">
-                      <a:solidFill>
-                        <a:srgbClr val="DCDDE0"/>
-                      </a:solidFill>
-                      <a:prstDash val="solid"/>
-                      <a:round/>
-                      <a:headEnd type="none" w="med" len="med"/>
-                      <a:tailEnd type="none" w="med" len="med"/>
-                    </a:lnT>
-                    <a:lnB w="9525" cap="flat" cmpd="sng" algn="ctr">
-                      <a:solidFill>
-                        <a:srgbClr val="DCDDE0"/>
-                      </a:solidFill>
-                      <a:prstDash val="solid"/>
-                      <a:round/>
-                      <a:headEnd type="none" w="med" len="med"/>
-                      <a:tailEnd type="none" w="med" len="med"/>
-                    </a:lnB>
-                  </a:tcPr>
+                  <a:tcPr marL="137160" marR="137160" marT="73152" marB="73152" anchor="ctr"/>
                 </a:tc>
                 <a:tc>
                   <a:txBody>
                     <a:bodyPr/>
                     <a:lstStyle/>
                     <a:p>
-                      <a:pPr indent="0" marL="0">
-                        <a:buNone/>
-                      </a:pPr>
-                      <a:r>
-                        <a:rPr lang="en-US" sz="1400" dirty="0">
-                          <a:solidFill>
-                            <a:schemeClr val="tx1"/>
-                          </a:solidFill>
-                          <a:latin typeface="Arial" pitchFamily="34" charset="0"/>
-                          <a:ea typeface="Arial" pitchFamily="34" charset="-122"/>
-                          <a:cs typeface="Arial" pitchFamily="34" charset="-120"/>
-                        </a:rPr>
-                        <a:t>Three headline numbers</a:t>
-                      </a:r>
-                      <a:endParaRPr lang="en-US" sz="1400" dirty="0">
-                        <a:latin typeface="Arial" charset="0"/>
-                        <a:ea typeface="Arial" charset="0"/>
-                        <a:cs typeface="Arial" charset="0"/>
-                      </a:endParaRPr>
+                      <a:endParaRPr lang="en-US" sz="1400" dirty="0"/>
                     </a:p>
                   </a:txBody>
-                  <a:tcPr marL="137160" marR="137160" marT="73152" marB="73152" anchor="ctr">
-                    <a:lnL w="9525" cap="flat" cmpd="sng" algn="ctr">
-                      <a:solidFill>
-                        <a:srgbClr val="DCDDE0"/>
-                      </a:solidFill>
-                      <a:prstDash val="solid"/>
-                      <a:round/>
-                      <a:headEnd type="none" w="med" len="med"/>
-                      <a:tailEnd type="none" w="med" len="med"/>
-                    </a:lnL>
-                    <a:lnR w="9525" cap="flat" cmpd="sng" algn="ctr">
-                      <a:solidFill>
-                        <a:srgbClr val="DCDDE0"/>
-                      </a:solidFill>
-                      <a:prstDash val="solid"/>
-                      <a:round/>
-                      <a:headEnd type="none" w="med" len="med"/>
-                      <a:tailEnd type="none" w="med" len="med"/>
-                    </a:lnR>
-                    <a:lnT w="9525" cap="flat" cmpd="sng" algn="ctr">
-                      <a:solidFill>
-                        <a:srgbClr val="DCDDE0"/>
-                      </a:solidFill>
-                      <a:prstDash val="solid"/>
-                      <a:round/>
-                      <a:headEnd type="none" w="med" len="med"/>
-                      <a:tailEnd type="none" w="med" len="med"/>
-                    </a:lnT>
-                    <a:lnB w="9525" cap="flat" cmpd="sng" algn="ctr">
-                      <a:solidFill>
-                        <a:srgbClr val="DCDDE0"/>
-                      </a:solidFill>
-                      <a:prstDash val="solid"/>
-                      <a:round/>
-                      <a:headEnd type="none" w="med" len="med"/>
-                      <a:tailEnd type="none" w="med" len="med"/>
-                    </a:lnB>
-                  </a:tcPr>
+                  <a:tcPr marL="137160" marR="137160" marT="73152" marB="73152" anchor="ctr"/>
                 </a:tc>
                 <a:tc>
                   <a:txBody>
                     <a:bodyPr/>
                     <a:lstStyle/>
                     <a:p>
-                      <a:pPr indent="0" marL="0">
-                        <a:buNone/>
-                      </a:pPr>
-                      <a:r>
-                        <a:rPr lang="en-US" sz="1400" dirty="0">
-                          <a:solidFill>
-                            <a:schemeClr val="tx1"/>
-                          </a:solidFill>
-                          <a:latin typeface="Arial" pitchFamily="34" charset="0"/>
-                          <a:ea typeface="Arial" pitchFamily="34" charset="-122"/>
-                          <a:cs typeface="Arial" pitchFamily="34" charset="-120"/>
-                        </a:rPr>
-                        <a:t>stat1..3_value, stat1..3_label, caption</a:t>
-                      </a:r>
-                      <a:endParaRPr lang="en-US" sz="1400" dirty="0">
-                        <a:latin typeface="Arial" charset="0"/>
-                        <a:ea typeface="Arial" charset="0"/>
-                        <a:cs typeface="Arial" charset="0"/>
-                      </a:endParaRPr>
+                      <a:endParaRPr lang="en-US" sz="1400" dirty="0"/>
                     </a:p>
                   </a:txBody>
-                  <a:tcPr marL="137160" marR="137160" marT="73152" marB="73152" anchor="ctr">
-                    <a:lnL w="9525" cap="flat" cmpd="sng" algn="ctr">
-                      <a:solidFill>
-                        <a:srgbClr val="DCDDE0"/>
-                      </a:solidFill>
-                      <a:prstDash val="solid"/>
-                      <a:round/>
-                      <a:headEnd type="none" w="med" len="med"/>
-                      <a:tailEnd type="none" w="med" len="med"/>
-                    </a:lnL>
-                    <a:lnR w="9525" cap="flat" cmpd="sng" algn="ctr">
-                      <a:solidFill>
-                        <a:srgbClr val="DCDDE0"/>
-                      </a:solidFill>
-                      <a:prstDash val="solid"/>
-                      <a:round/>
-                      <a:headEnd type="none" w="med" len="med"/>
-                      <a:tailEnd type="none" w="med" len="med"/>
-                    </a:lnR>
-                    <a:lnT w="9525" cap="flat" cmpd="sng" algn="ctr">
-                      <a:solidFill>
-                        <a:srgbClr val="DCDDE0"/>
-                      </a:solidFill>
-                      <a:prstDash val="solid"/>
-                      <a:round/>
-                      <a:headEnd type="none" w="med" len="med"/>
-                      <a:tailEnd type="none" w="med" len="med"/>
-                    </a:lnT>
-                    <a:lnB w="9525" cap="flat" cmpd="sng" algn="ctr">
-                      <a:solidFill>
-                        <a:srgbClr val="DCDDE0"/>
-                      </a:solidFill>
-                      <a:prstDash val="solid"/>
-                      <a:round/>
-                      <a:headEnd type="none" w="med" len="med"/>
-                      <a:tailEnd type="none" w="med" len="med"/>
-                    </a:lnB>
-                  </a:tcPr>
+                  <a:tcPr marL="137160" marR="137160" marT="73152" marB="73152" anchor="ctr"/>
                 </a:tc>
               </a:tr>
-              <a:tr h="502920">
+              <a:tr h="402336">
                 <a:tc>
                   <a:txBody>
                     <a:bodyPr/>
                     <a:lstStyle/>
                     <a:p>
-                      <a:pPr indent="0" marL="0">
-                        <a:buNone/>
-                      </a:pPr>
-                      <a:r>
-                        <a:rPr lang="en-US" sz="1400" dirty="0">
-                          <a:solidFill>
-                            <a:schemeClr val="tx1"/>
-                          </a:solidFill>
-                          <a:latin typeface="Arial" pitchFamily="34" charset="0"/>
-                          <a:ea typeface="Arial" pitchFamily="34" charset="-122"/>
-                          <a:cs typeface="Arial" pitchFamily="34" charset="-120"/>
-                        </a:rPr>
-                        <a:t>Fred Process</a:t>
-                      </a:r>
-                      <a:endParaRPr lang="en-US" sz="1400" dirty="0">
-                        <a:latin typeface="Arial" charset="0"/>
-                        <a:ea typeface="Arial" charset="0"/>
-                        <a:cs typeface="Arial" charset="0"/>
-                      </a:endParaRPr>
+                      <a:endParaRPr lang="en-US" sz="1400" dirty="0"/>
                     </a:p>
                   </a:txBody>
-                  <a:tcPr marL="137160" marR="137160" marT="73152" marB="73152" anchor="ctr">
-                    <a:lnL w="9525" cap="flat" cmpd="sng" algn="ctr">
-                      <a:solidFill>
-                        <a:srgbClr val="DCDDE0"/>
-                      </a:solidFill>
-                      <a:prstDash val="solid"/>
-                      <a:round/>
-                      <a:headEnd type="none" w="med" len="med"/>
-                      <a:tailEnd type="none" w="med" len="med"/>
-                    </a:lnL>
-                    <a:lnR w="9525" cap="flat" cmpd="sng" algn="ctr">
-                      <a:solidFill>
-                        <a:srgbClr val="DCDDE0"/>
-                      </a:solidFill>
-                      <a:prstDash val="solid"/>
-                      <a:round/>
-                      <a:headEnd type="none" w="med" len="med"/>
-                      <a:tailEnd type="none" w="med" len="med"/>
-                    </a:lnR>
-                    <a:lnT w="9525" cap="flat" cmpd="sng" algn="ctr">
-                      <a:solidFill>
-                        <a:srgbClr val="DCDDE0"/>
-                      </a:solidFill>
-                      <a:prstDash val="solid"/>
-                      <a:round/>
-                      <a:headEnd type="none" w="med" len="med"/>
-                      <a:tailEnd type="none" w="med" len="med"/>
-                    </a:lnT>
-                    <a:lnB w="9525" cap="flat" cmpd="sng" algn="ctr">
-                      <a:solidFill>
-                        <a:srgbClr val="DCDDE0"/>
-                      </a:solidFill>
-                      <a:prstDash val="solid"/>
-                      <a:round/>
-                      <a:headEnd type="none" w="med" len="med"/>
-                      <a:tailEnd type="none" w="med" len="med"/>
-                    </a:lnB>
-                  </a:tcPr>
+                  <a:tcPr marL="137160" marR="137160" marT="73152" marB="73152" anchor="ctr"/>
                 </a:tc>
                 <a:tc>
                   <a:txBody>
                     <a:bodyPr/>
                     <a:lstStyle/>
                     <a:p>
-                      <a:pPr indent="0" marL="0">
-                        <a:buNone/>
-                      </a:pPr>
-                      <a:r>
-                        <a:rPr lang="en-US" sz="1400" dirty="0">
-                          <a:solidFill>
-                            <a:schemeClr val="tx1"/>
-                          </a:solidFill>
-                          <a:latin typeface="Arial" pitchFamily="34" charset="0"/>
-                          <a:ea typeface="Arial" pitchFamily="34" charset="-122"/>
-                          <a:cs typeface="Arial" pitchFamily="34" charset="-120"/>
-                        </a:rPr>
-                        <a:t>Four-step sequence</a:t>
-                      </a:r>
-                      <a:endParaRPr lang="en-US" sz="1400" dirty="0">
-                        <a:latin typeface="Arial" charset="0"/>
-                        <a:ea typeface="Arial" charset="0"/>
-                        <a:cs typeface="Arial" charset="0"/>
-                      </a:endParaRPr>
+                      <a:endParaRPr lang="en-US" sz="1400" dirty="0"/>
                     </a:p>
                   </a:txBody>
-                  <a:tcPr marL="137160" marR="137160" marT="73152" marB="73152" anchor="ctr">
-                    <a:lnL w="9525" cap="flat" cmpd="sng" algn="ctr">
-                      <a:solidFill>
-                        <a:srgbClr val="DCDDE0"/>
-                      </a:solidFill>
-                      <a:prstDash val="solid"/>
-                      <a:round/>
-                      <a:headEnd type="none" w="med" len="med"/>
-                      <a:tailEnd type="none" w="med" len="med"/>
-                    </a:lnL>
-                    <a:lnR w="9525" cap="flat" cmpd="sng" algn="ctr">
-                      <a:solidFill>
-                        <a:srgbClr val="DCDDE0"/>
-                      </a:solidFill>
-                      <a:prstDash val="solid"/>
-                      <a:round/>
-                      <a:headEnd type="none" w="med" len="med"/>
-                      <a:tailEnd type="none" w="med" len="med"/>
-                    </a:lnR>
-                    <a:lnT w="9525" cap="flat" cmpd="sng" algn="ctr">
-                      <a:solidFill>
-                        <a:srgbClr val="DCDDE0"/>
-                      </a:solidFill>
-                      <a:prstDash val="solid"/>
-                      <a:round/>
-                      <a:headEnd type="none" w="med" len="med"/>
-                      <a:tailEnd type="none" w="med" len="med"/>
-                    </a:lnT>
-                    <a:lnB w="9525" cap="flat" cmpd="sng" algn="ctr">
-                      <a:solidFill>
-                        <a:srgbClr val="DCDDE0"/>
-                      </a:solidFill>
-                      <a:prstDash val="solid"/>
-                      <a:round/>
-                      <a:headEnd type="none" w="med" len="med"/>
-                      <a:tailEnd type="none" w="med" len="med"/>
-                    </a:lnB>
-                  </a:tcPr>
+                  <a:tcPr marL="137160" marR="137160" marT="73152" marB="73152" anchor="ctr"/>
                 </a:tc>
                 <a:tc>
                   <a:txBody>
                     <a:bodyPr/>
                     <a:lstStyle/>
                     <a:p>
-                      <a:pPr indent="0" marL="0">
-                        <a:buNone/>
-                      </a:pPr>
-                      <a:r>
-                        <a:rPr lang="en-US" sz="1400" dirty="0">
-                          <a:solidFill>
-                            <a:schemeClr val="tx1"/>
-                          </a:solidFill>
-                          <a:latin typeface="Arial" pitchFamily="34" charset="0"/>
-                          <a:ea typeface="Arial" pitchFamily="34" charset="-122"/>
-                          <a:cs typeface="Arial" pitchFamily="34" charset="-120"/>
-                        </a:rPr>
-                        <a:t>step1..4_title, step1..4_body</a:t>
-                      </a:r>
-                      <a:endParaRPr lang="en-US" sz="1400" dirty="0">
-                        <a:latin typeface="Arial" charset="0"/>
-                        <a:ea typeface="Arial" charset="0"/>
-                        <a:cs typeface="Arial" charset="0"/>
-                      </a:endParaRPr>
+                      <a:endParaRPr lang="en-US" sz="1400" dirty="0"/>
                     </a:p>
                   </a:txBody>
-                  <a:tcPr marL="137160" marR="137160" marT="73152" marB="73152" anchor="ctr">
-                    <a:lnL w="9525" cap="flat" cmpd="sng" algn="ctr">
-                      <a:solidFill>
-                        <a:srgbClr val="DCDDE0"/>
-                      </a:solidFill>
-                      <a:prstDash val="solid"/>
-                      <a:round/>
-                      <a:headEnd type="none" w="med" len="med"/>
-                      <a:tailEnd type="none" w="med" len="med"/>
-                    </a:lnL>
-                    <a:lnR w="9525" cap="flat" cmpd="sng" algn="ctr">
-                      <a:solidFill>
-                        <a:srgbClr val="DCDDE0"/>
-                      </a:solidFill>
-                      <a:prstDash val="solid"/>
-                      <a:round/>
-                      <a:headEnd type="none" w="med" len="med"/>
-                      <a:tailEnd type="none" w="med" len="med"/>
-                    </a:lnR>
-                    <a:lnT w="9525" cap="flat" cmpd="sng" algn="ctr">
-                      <a:solidFill>
-                        <a:srgbClr val="DCDDE0"/>
-                      </a:solidFill>
-                      <a:prstDash val="solid"/>
-                      <a:round/>
-                      <a:headEnd type="none" w="med" len="med"/>
-                      <a:tailEnd type="none" w="med" len="med"/>
-                    </a:lnT>
-                    <a:lnB w="9525" cap="flat" cmpd="sng" algn="ctr">
-                      <a:solidFill>
-                        <a:srgbClr val="DCDDE0"/>
-                      </a:solidFill>
-                      <a:prstDash val="solid"/>
-                      <a:round/>
-                      <a:headEnd type="none" w="med" len="med"/>
-                      <a:tailEnd type="none" w="med" len="med"/>
-                    </a:lnB>
-                  </a:tcPr>
-                </a:tc>
-              </a:tr>
-              <a:tr h="502920">
-                <a:tc>
-                  <a:txBody>
-                    <a:bodyPr/>
-                    <a:lstStyle/>
-                    <a:p>
-                      <a:pPr indent="0" marL="0">
-                        <a:buNone/>
-                      </a:pPr>
-                      <a:r>
-                        <a:rPr lang="en-US" sz="1400" dirty="0">
-                          <a:solidFill>
-                            <a:schemeClr val="tx1"/>
-                          </a:solidFill>
-                          <a:latin typeface="Arial" pitchFamily="34" charset="0"/>
-                          <a:ea typeface="Arial" pitchFamily="34" charset="-122"/>
-                          <a:cs typeface="Arial" pitchFamily="34" charset="-120"/>
-                        </a:rPr>
-                        <a:t>Fred Chart</a:t>
-                      </a:r>
-                      <a:endParaRPr lang="en-US" sz="1400" dirty="0">
-                        <a:latin typeface="Arial" charset="0"/>
-                        <a:ea typeface="Arial" charset="0"/>
-                        <a:cs typeface="Arial" charset="0"/>
-                      </a:endParaRPr>
-                    </a:p>
-                  </a:txBody>
-                  <a:tcPr marL="137160" marR="137160" marT="73152" marB="73152" anchor="ctr">
-                    <a:lnL w="9525" cap="flat" cmpd="sng" algn="ctr">
-                      <a:solidFill>
-                        <a:srgbClr val="DCDDE0"/>
-                      </a:solidFill>
-                      <a:prstDash val="solid"/>
-                      <a:round/>
-                      <a:headEnd type="none" w="med" len="med"/>
-                      <a:tailEnd type="none" w="med" len="med"/>
-                    </a:lnL>
-                    <a:lnR w="9525" cap="flat" cmpd="sng" algn="ctr">
-                      <a:solidFill>
-                        <a:srgbClr val="DCDDE0"/>
-                      </a:solidFill>
-                      <a:prstDash val="solid"/>
-                      <a:round/>
-                      <a:headEnd type="none" w="med" len="med"/>
-                      <a:tailEnd type="none" w="med" len="med"/>
-                    </a:lnR>
-                    <a:lnT w="9525" cap="flat" cmpd="sng" algn="ctr">
-                      <a:solidFill>
-                        <a:srgbClr val="DCDDE0"/>
-                      </a:solidFill>
-                      <a:prstDash val="solid"/>
-                      <a:round/>
-                      <a:headEnd type="none" w="med" len="med"/>
-                      <a:tailEnd type="none" w="med" len="med"/>
-                    </a:lnT>
-                    <a:lnB w="9525" cap="flat" cmpd="sng" algn="ctr">
-                      <a:solidFill>
-                        <a:srgbClr val="DCDDE0"/>
-                      </a:solidFill>
-                      <a:prstDash val="solid"/>
-                      <a:round/>
-                      <a:headEnd type="none" w="med" len="med"/>
-                      <a:tailEnd type="none" w="med" len="med"/>
-                    </a:lnB>
-                  </a:tcPr>
+                  <a:tcPr marL="137160" marR="137160" marT="73152" marB="73152" anchor="ctr"/>
                 </a:tc>
                 <a:tc>
                   <a:txBody>
                     <a:bodyPr/>
                     <a:lstStyle/>
                     <a:p>
-                      <a:pPr indent="0" marL="0">
-                        <a:buNone/>
-                      </a:pPr>
-                      <a:r>
-                        <a:rPr lang="en-US" sz="1400" dirty="0">
-                          <a:solidFill>
-                            <a:schemeClr val="tx1"/>
-                          </a:solidFill>
-                          <a:latin typeface="Arial" pitchFamily="34" charset="0"/>
-                          <a:ea typeface="Arial" pitchFamily="34" charset="-122"/>
-                          <a:cs typeface="Arial" pitchFamily="34" charset="-120"/>
-                        </a:rPr>
-                        <a:t>One chart and its takeaway</a:t>
-                      </a:r>
-                      <a:endParaRPr lang="en-US" sz="1400" dirty="0">
-                        <a:latin typeface="Arial" charset="0"/>
-                        <a:ea typeface="Arial" charset="0"/>
-                        <a:cs typeface="Arial" charset="0"/>
-                      </a:endParaRPr>
+                      <a:endParaRPr lang="en-US" sz="1400" dirty="0"/>
                     </a:p>
                   </a:txBody>
-                  <a:tcPr marL="137160" marR="137160" marT="73152" marB="73152" anchor="ctr">
-                    <a:lnL w="9525" cap="flat" cmpd="sng" algn="ctr">
-                      <a:solidFill>
-                        <a:srgbClr val="DCDDE0"/>
-                      </a:solidFill>
-                      <a:prstDash val="solid"/>
-                      <a:round/>
-                      <a:headEnd type="none" w="med" len="med"/>
-                      <a:tailEnd type="none" w="med" len="med"/>
-                    </a:lnL>
-                    <a:lnR w="9525" cap="flat" cmpd="sng" algn="ctr">
-                      <a:solidFill>
-                        <a:srgbClr val="DCDDE0"/>
-                      </a:solidFill>
-                      <a:prstDash val="solid"/>
-                      <a:round/>
-                      <a:headEnd type="none" w="med" len="med"/>
-                      <a:tailEnd type="none" w="med" len="med"/>
-                    </a:lnR>
-                    <a:lnT w="9525" cap="flat" cmpd="sng" algn="ctr">
-                      <a:solidFill>
-                        <a:srgbClr val="DCDDE0"/>
-                      </a:solidFill>
-                      <a:prstDash val="solid"/>
-                      <a:round/>
-                      <a:headEnd type="none" w="med" len="med"/>
-                      <a:tailEnd type="none" w="med" len="med"/>
-                    </a:lnT>
-                    <a:lnB w="9525" cap="flat" cmpd="sng" algn="ctr">
-                      <a:solidFill>
-                        <a:srgbClr val="DCDDE0"/>
-                      </a:solidFill>
-                      <a:prstDash val="solid"/>
-                      <a:round/>
-                      <a:headEnd type="none" w="med" len="med"/>
-                      <a:tailEnd type="none" w="med" len="med"/>
-                    </a:lnB>
-                  </a:tcPr>
+                  <a:tcPr marL="137160" marR="137160" marT="73152" marB="73152" anchor="ctr"/>
                 </a:tc>
                 <a:tc>
                   <a:txBody>
                     <a:bodyPr/>
                     <a:lstStyle/>
                     <a:p>
-                      <a:pPr indent="0" marL="0">
-                        <a:buNone/>
-                      </a:pPr>
-                      <a:r>
-                        <a:rPr lang="en-US" sz="1400" dirty="0">
-                          <a:solidFill>
-                            <a:schemeClr val="tx1"/>
-                          </a:solidFill>
-                          <a:latin typeface="Arial" pitchFamily="34" charset="0"/>
-                          <a:ea typeface="Arial" pitchFamily="34" charset="-122"/>
-                          <a:cs typeface="Arial" pitchFamily="34" charset="-120"/>
-                        </a:rPr>
-                        <a:t>chart, takeaway</a:t>
-                      </a:r>
-                      <a:endParaRPr lang="en-US" sz="1400" dirty="0">
-                        <a:latin typeface="Arial" charset="0"/>
-                        <a:ea typeface="Arial" charset="0"/>
-                        <a:cs typeface="Arial" charset="0"/>
-                      </a:endParaRPr>
+                      <a:endParaRPr lang="en-US" sz="1400" dirty="0"/>
                     </a:p>
                   </a:txBody>
-                  <a:tcPr marL="137160" marR="137160" marT="73152" marB="73152" anchor="ctr">
-                    <a:lnL w="9525" cap="flat" cmpd="sng" algn="ctr">
-                      <a:solidFill>
-                        <a:srgbClr val="DCDDE0"/>
-                      </a:solidFill>
-                      <a:prstDash val="solid"/>
-                      <a:round/>
-                      <a:headEnd type="none" w="med" len="med"/>
-                      <a:tailEnd type="none" w="med" len="med"/>
-                    </a:lnL>
-                    <a:lnR w="9525" cap="flat" cmpd="sng" algn="ctr">
-                      <a:solidFill>
-                        <a:srgbClr val="DCDDE0"/>
-                      </a:solidFill>
-                      <a:prstDash val="solid"/>
-                      <a:round/>
-                      <a:headEnd type="none" w="med" len="med"/>
-                      <a:tailEnd type="none" w="med" len="med"/>
-                    </a:lnR>
-                    <a:lnT w="9525" cap="flat" cmpd="sng" algn="ctr">
-                      <a:solidFill>
-                        <a:srgbClr val="DCDDE0"/>
-                      </a:solidFill>
-                      <a:prstDash val="solid"/>
-                      <a:round/>
-                      <a:headEnd type="none" w="med" len="med"/>
-                      <a:tailEnd type="none" w="med" len="med"/>
-                    </a:lnT>
-                    <a:lnB w="9525" cap="flat" cmpd="sng" algn="ctr">
-                      <a:solidFill>
-                        <a:srgbClr val="DCDDE0"/>
-                      </a:solidFill>
-                      <a:prstDash val="solid"/>
-                      <a:round/>
-                      <a:headEnd type="none" w="med" len="med"/>
-                      <a:tailEnd type="none" w="med" len="med"/>
-                    </a:lnB>
-                  </a:tcPr>
+                  <a:tcPr marL="137160" marR="137160" marT="73152" marB="73152" anchor="ctr"/>
                 </a:tc>
               </a:tr>
-              <a:tr h="502920">
+              <a:tr h="402336">
                 <a:tc>
                   <a:txBody>
                     <a:bodyPr/>
                     <a:lstStyle/>
                     <a:p>
-                      <a:pPr indent="0" marL="0">
-                        <a:buNone/>
-                      </a:pPr>
-                      <a:r>
-                        <a:rPr lang="en-US" sz="1400" dirty="0">
-                          <a:solidFill>
-                            <a:schemeClr val="tx1"/>
-                          </a:solidFill>
-                          <a:latin typeface="Arial" pitchFamily="34" charset="0"/>
-                          <a:ea typeface="Arial" pitchFamily="34" charset="-122"/>
-                          <a:cs typeface="Arial" pitchFamily="34" charset="-120"/>
-                        </a:rPr>
-                        <a:t>Fred Title Only</a:t>
-                      </a:r>
-                      <a:endParaRPr lang="en-US" sz="1400" dirty="0">
-                        <a:latin typeface="Arial" charset="0"/>
-                        <a:ea typeface="Arial" charset="0"/>
-                        <a:cs typeface="Arial" charset="0"/>
-                      </a:endParaRPr>
+                      <a:endParaRPr lang="en-US" sz="1400" dirty="0"/>
                     </a:p>
                   </a:txBody>
-                  <a:tcPr marL="137160" marR="137160" marT="73152" marB="73152" anchor="ctr">
-                    <a:lnL w="9525" cap="flat" cmpd="sng" algn="ctr">
-                      <a:solidFill>
-                        <a:srgbClr val="DCDDE0"/>
-                      </a:solidFill>
-                      <a:prstDash val="solid"/>
-                      <a:round/>
-                      <a:headEnd type="none" w="med" len="med"/>
-                      <a:tailEnd type="none" w="med" len="med"/>
-                    </a:lnL>
-                    <a:lnR w="9525" cap="flat" cmpd="sng" algn="ctr">
-                      <a:solidFill>
-                        <a:srgbClr val="DCDDE0"/>
-                      </a:solidFill>
-                      <a:prstDash val="solid"/>
-                      <a:round/>
-                      <a:headEnd type="none" w="med" len="med"/>
-                      <a:tailEnd type="none" w="med" len="med"/>
-                    </a:lnR>
-                    <a:lnT w="9525" cap="flat" cmpd="sng" algn="ctr">
-                      <a:solidFill>
-                        <a:srgbClr val="DCDDE0"/>
-                      </a:solidFill>
-                      <a:prstDash val="solid"/>
-                      <a:round/>
-                      <a:headEnd type="none" w="med" len="med"/>
-                      <a:tailEnd type="none" w="med" len="med"/>
-                    </a:lnT>
-                    <a:lnB w="9525" cap="flat" cmpd="sng" algn="ctr">
-                      <a:solidFill>
-                        <a:srgbClr val="DCDDE0"/>
-                      </a:solidFill>
-                      <a:prstDash val="solid"/>
-                      <a:round/>
-                      <a:headEnd type="none" w="med" len="med"/>
-                      <a:tailEnd type="none" w="med" len="med"/>
-                    </a:lnB>
-                  </a:tcPr>
+                  <a:tcPr marL="137160" marR="137160" marT="73152" marB="73152" anchor="ctr"/>
                 </a:tc>
                 <a:tc>
                   <a:txBody>
                     <a:bodyPr/>
                     <a:lstStyle/>
                     <a:p>
-                      <a:pPr indent="0" marL="0">
-                        <a:buNone/>
-                      </a:pPr>
-                      <a:r>
-                        <a:rPr lang="en-US" sz="1400" dirty="0">
-                          <a:solidFill>
-                            <a:schemeClr val="tx1"/>
-                          </a:solidFill>
-                          <a:latin typeface="Arial" pitchFamily="34" charset="0"/>
-                          <a:ea typeface="Arial" pitchFamily="34" charset="-122"/>
-                          <a:cs typeface="Arial" pitchFamily="34" charset="-120"/>
-                        </a:rPr>
-                        <a:t>Free composition</a:t>
-                      </a:r>
-                      <a:endParaRPr lang="en-US" sz="1400" dirty="0">
-                        <a:latin typeface="Arial" charset="0"/>
-                        <a:ea typeface="Arial" charset="0"/>
-                        <a:cs typeface="Arial" charset="0"/>
-                      </a:endParaRPr>
+                      <a:endParaRPr lang="en-US" sz="1400" dirty="0"/>
                     </a:p>
                   </a:txBody>
-                  <a:tcPr marL="137160" marR="137160" marT="73152" marB="73152" anchor="ctr">
-                    <a:lnL w="9525" cap="flat" cmpd="sng" algn="ctr">
-                      <a:solidFill>
-                        <a:srgbClr val="DCDDE0"/>
-                      </a:solidFill>
-                      <a:prstDash val="solid"/>
-                      <a:round/>
-                      <a:headEnd type="none" w="med" len="med"/>
-                      <a:tailEnd type="none" w="med" len="med"/>
-                    </a:lnL>
-                    <a:lnR w="9525" cap="flat" cmpd="sng" algn="ctr">
-                      <a:solidFill>
-                        <a:srgbClr val="DCDDE0"/>
-                      </a:solidFill>
-                      <a:prstDash val="solid"/>
-                      <a:round/>
-                      <a:headEnd type="none" w="med" len="med"/>
-                      <a:tailEnd type="none" w="med" len="med"/>
-                    </a:lnR>
-                    <a:lnT w="9525" cap="flat" cmpd="sng" algn="ctr">
-                      <a:solidFill>
-                        <a:srgbClr val="DCDDE0"/>
-                      </a:solidFill>
-                      <a:prstDash val="solid"/>
-                      <a:round/>
-                      <a:headEnd type="none" w="med" len="med"/>
-                      <a:tailEnd type="none" w="med" len="med"/>
-                    </a:lnT>
-                    <a:lnB w="9525" cap="flat" cmpd="sng" algn="ctr">
-                      <a:solidFill>
-                        <a:srgbClr val="DCDDE0"/>
-                      </a:solidFill>
-                      <a:prstDash val="solid"/>
-                      <a:round/>
-                      <a:headEnd type="none" w="med" len="med"/>
-                      <a:tailEnd type="none" w="med" len="med"/>
-                    </a:lnB>
-                  </a:tcPr>
+                  <a:tcPr marL="137160" marR="137160" marT="73152" marB="73152" anchor="ctr"/>
                 </a:tc>
                 <a:tc>
                   <a:txBody>
                     <a:bodyPr/>
                     <a:lstStyle/>
                     <a:p>
-                      <a:pPr indent="0" marL="0">
-                        <a:buNone/>
-                      </a:pPr>
-                      <a:r>
-                        <a:rPr lang="en-US" sz="1400" dirty="0">
-                          <a:solidFill>
-                            <a:schemeClr val="tx1"/>
-                          </a:solidFill>
-                          <a:latin typeface="Arial" pitchFamily="34" charset="0"/>
-                          <a:ea typeface="Arial" pitchFamily="34" charset="-122"/>
-                          <a:cs typeface="Arial" pitchFamily="34" charset="-120"/>
-                        </a:rPr>
-                        <a:t>title</a:t>
-                      </a:r>
-                      <a:endParaRPr lang="en-US" sz="1400" dirty="0">
-                        <a:latin typeface="Arial" charset="0"/>
-                        <a:ea typeface="Arial" charset="0"/>
-                        <a:cs typeface="Arial" charset="0"/>
-                      </a:endParaRPr>
+                      <a:endParaRPr lang="en-US" sz="1400" dirty="0"/>
                     </a:p>
                   </a:txBody>
-                  <a:tcPr marL="137160" marR="137160" marT="73152" marB="73152" anchor="ctr">
-                    <a:lnL w="9525" cap="flat" cmpd="sng" algn="ctr">
-                      <a:solidFill>
-                        <a:srgbClr val="DCDDE0"/>
-                      </a:solidFill>
-                      <a:prstDash val="solid"/>
-                      <a:round/>
-                      <a:headEnd type="none" w="med" len="med"/>
-                      <a:tailEnd type="none" w="med" len="med"/>
-                    </a:lnL>
-                    <a:lnR w="9525" cap="flat" cmpd="sng" algn="ctr">
-                      <a:solidFill>
-                        <a:srgbClr val="DCDDE0"/>
-                      </a:solidFill>
-                      <a:prstDash val="solid"/>
-                      <a:round/>
-                      <a:headEnd type="none" w="med" len="med"/>
-                      <a:tailEnd type="none" w="med" len="med"/>
-                    </a:lnR>
-                    <a:lnT w="9525" cap="flat" cmpd="sng" algn="ctr">
-                      <a:solidFill>
-                        <a:srgbClr val="DCDDE0"/>
-                      </a:solidFill>
-                      <a:prstDash val="solid"/>
-                      <a:round/>
-                      <a:headEnd type="none" w="med" len="med"/>
-                      <a:tailEnd type="none" w="med" len="med"/>
-                    </a:lnT>
-                    <a:lnB w="9525" cap="flat" cmpd="sng" algn="ctr">
-                      <a:solidFill>
-                        <a:srgbClr val="DCDDE0"/>
-                      </a:solidFill>
-                      <a:prstDash val="solid"/>
-                      <a:round/>
-                      <a:headEnd type="none" w="med" len="med"/>
-                      <a:tailEnd type="none" w="med" len="med"/>
-                    </a:lnB>
-                  </a:tcPr>
+                  <a:tcPr marL="137160" marR="137160" marT="73152" marB="73152" anchor="ctr"/>
+                </a:tc>
+                <a:tc>
+                  <a:txBody>
+                    <a:bodyPr/>
+                    <a:lstStyle/>
+                    <a:p>
+                      <a:endParaRPr lang="en-US" sz="1400" dirty="0"/>
+                    </a:p>
+                  </a:txBody>
+                  <a:tcPr marL="137160" marR="137160" marT="73152" marB="73152" anchor="ctr"/>
+                </a:tc>
+                <a:tc>
+                  <a:txBody>
+                    <a:bodyPr/>
+                    <a:lstStyle/>
+                    <a:p>
+                      <a:endParaRPr lang="en-US" sz="1400" dirty="0"/>
+                    </a:p>
+                  </a:txBody>
+                  <a:tcPr marL="137160" marR="137160" marT="73152" marB="73152" anchor="ctr"/>
+                </a:tc>
+              </a:tr>
+              <a:tr h="402336">
+                <a:tc>
+                  <a:txBody>
+                    <a:bodyPr/>
+                    <a:lstStyle/>
+                    <a:p>
+                      <a:endParaRPr lang="en-US" sz="1400" dirty="0"/>
+                    </a:p>
+                  </a:txBody>
+                  <a:tcPr marL="137160" marR="137160" marT="73152" marB="73152" anchor="ctr"/>
+                </a:tc>
+                <a:tc>
+                  <a:txBody>
+                    <a:bodyPr/>
+                    <a:lstStyle/>
+                    <a:p>
+                      <a:endParaRPr lang="en-US" sz="1400" dirty="0"/>
+                    </a:p>
+                  </a:txBody>
+                  <a:tcPr marL="137160" marR="137160" marT="73152" marB="73152" anchor="ctr"/>
+                </a:tc>
+                <a:tc>
+                  <a:txBody>
+                    <a:bodyPr/>
+                    <a:lstStyle/>
+                    <a:p>
+                      <a:endParaRPr lang="en-US" sz="1400" dirty="0"/>
+                    </a:p>
+                  </a:txBody>
+                  <a:tcPr marL="137160" marR="137160" marT="73152" marB="73152" anchor="ctr"/>
+                </a:tc>
+                <a:tc>
+                  <a:txBody>
+                    <a:bodyPr/>
+                    <a:lstStyle/>
+                    <a:p>
+                      <a:endParaRPr lang="en-US" sz="1400" dirty="0"/>
+                    </a:p>
+                  </a:txBody>
+                  <a:tcPr marL="137160" marR="137160" marT="73152" marB="73152" anchor="ctr"/>
+                </a:tc>
+                <a:tc>
+                  <a:txBody>
+                    <a:bodyPr/>
+                    <a:lstStyle/>
+                    <a:p>
+                      <a:endParaRPr lang="en-US" sz="1400" dirty="0"/>
+                    </a:p>
+                  </a:txBody>
+                  <a:tcPr marL="137160" marR="137160" marT="73152" marB="73152" anchor="ctr"/>
+                </a:tc>
+              </a:tr>
+              <a:tr h="402336">
+                <a:tc>
+                  <a:txBody>
+                    <a:bodyPr/>
+                    <a:lstStyle/>
+                    <a:p>
+                      <a:endParaRPr lang="en-US" sz="1400" dirty="0"/>
+                    </a:p>
+                  </a:txBody>
+                  <a:tcPr marL="137160" marR="137160" marT="73152" marB="73152" anchor="ctr"/>
+                </a:tc>
+                <a:tc>
+                  <a:txBody>
+                    <a:bodyPr/>
+                    <a:lstStyle/>
+                    <a:p>
+                      <a:endParaRPr lang="en-US" sz="1400" dirty="0"/>
+                    </a:p>
+                  </a:txBody>
+                  <a:tcPr marL="137160" marR="137160" marT="73152" marB="73152" anchor="ctr"/>
+                </a:tc>
+                <a:tc>
+                  <a:txBody>
+                    <a:bodyPr/>
+                    <a:lstStyle/>
+                    <a:p>
+                      <a:endParaRPr lang="en-US" sz="1400" dirty="0"/>
+                    </a:p>
+                  </a:txBody>
+                  <a:tcPr marL="137160" marR="137160" marT="73152" marB="73152" anchor="ctr"/>
+                </a:tc>
+                <a:tc>
+                  <a:txBody>
+                    <a:bodyPr/>
+                    <a:lstStyle/>
+                    <a:p>
+                      <a:endParaRPr lang="en-US" sz="1400" dirty="0"/>
+                    </a:p>
+                  </a:txBody>
+                  <a:tcPr marL="137160" marR="137160" marT="73152" marB="73152" anchor="ctr"/>
+                </a:tc>
+                <a:tc>
+                  <a:txBody>
+                    <a:bodyPr/>
+                    <a:lstStyle/>
+                    <a:p>
+                      <a:endParaRPr lang="en-US" sz="1400" dirty="0"/>
+                    </a:p>
+                  </a:txBody>
+                  <a:tcPr marL="137160" marR="137160" marT="73152" marB="73152" anchor="ctr"/>
+                </a:tc>
+              </a:tr>
+              <a:tr h="402336">
+                <a:tc>
+                  <a:txBody>
+                    <a:bodyPr/>
+                    <a:lstStyle/>
+                    <a:p>
+                      <a:endParaRPr lang="en-US" sz="1400" dirty="0"/>
+                    </a:p>
+                  </a:txBody>
+                  <a:tcPr marL="137160" marR="137160" marT="73152" marB="73152" anchor="ctr"/>
+                </a:tc>
+                <a:tc>
+                  <a:txBody>
+                    <a:bodyPr/>
+                    <a:lstStyle/>
+                    <a:p>
+                      <a:endParaRPr lang="en-US" sz="1400" dirty="0"/>
+                    </a:p>
+                  </a:txBody>
+                  <a:tcPr marL="137160" marR="137160" marT="73152" marB="73152" anchor="ctr"/>
+                </a:tc>
+                <a:tc>
+                  <a:txBody>
+                    <a:bodyPr/>
+                    <a:lstStyle/>
+                    <a:p>
+                      <a:endParaRPr lang="en-US" sz="1400" dirty="0"/>
+                    </a:p>
+                  </a:txBody>
+                  <a:tcPr marL="137160" marR="137160" marT="73152" marB="73152" anchor="ctr"/>
+                </a:tc>
+                <a:tc>
+                  <a:txBody>
+                    <a:bodyPr/>
+                    <a:lstStyle/>
+                    <a:p>
+                      <a:endParaRPr lang="en-US" sz="1400" dirty="0"/>
+                    </a:p>
+                  </a:txBody>
+                  <a:tcPr marL="137160" marR="137160" marT="73152" marB="73152" anchor="ctr"/>
+                </a:tc>
+                <a:tc>
+                  <a:txBody>
+                    <a:bodyPr/>
+                    <a:lstStyle/>
+                    <a:p>
+                      <a:endParaRPr lang="en-US" sz="1400" dirty="0"/>
+                    </a:p>
+                  </a:txBody>
+                  <a:tcPr marL="137160" marR="137160" marT="73152" marB="73152" anchor="ctr"/>
+                </a:tc>
+              </a:tr>
+              <a:tr h="402336">
+                <a:tc>
+                  <a:txBody>
+                    <a:bodyPr/>
+                    <a:lstStyle/>
+                    <a:p>
+                      <a:endParaRPr lang="en-US" sz="1400" dirty="0"/>
+                    </a:p>
+                  </a:txBody>
+                  <a:tcPr marL="137160" marR="137160" marT="73152" marB="73152" anchor="ctr"/>
+                </a:tc>
+                <a:tc>
+                  <a:txBody>
+                    <a:bodyPr/>
+                    <a:lstStyle/>
+                    <a:p>
+                      <a:endParaRPr lang="en-US" sz="1400" dirty="0"/>
+                    </a:p>
+                  </a:txBody>
+                  <a:tcPr marL="137160" marR="137160" marT="73152" marB="73152" anchor="ctr"/>
+                </a:tc>
+                <a:tc>
+                  <a:txBody>
+                    <a:bodyPr/>
+                    <a:lstStyle/>
+                    <a:p>
+                      <a:endParaRPr lang="en-US" sz="1400" dirty="0"/>
+                    </a:p>
+                  </a:txBody>
+                  <a:tcPr marL="137160" marR="137160" marT="73152" marB="73152" anchor="ctr"/>
+                </a:tc>
+                <a:tc>
+                  <a:txBody>
+                    <a:bodyPr/>
+                    <a:lstStyle/>
+                    <a:p>
+                      <a:endParaRPr lang="en-US" sz="1400" dirty="0"/>
+                    </a:p>
+                  </a:txBody>
+                  <a:tcPr marL="137160" marR="137160" marT="73152" marB="73152" anchor="ctr"/>
+                </a:tc>
+                <a:tc>
+                  <a:txBody>
+                    <a:bodyPr/>
+                    <a:lstStyle/>
+                    <a:p>
+                      <a:endParaRPr lang="en-US" sz="1400" dirty="0"/>
+                    </a:p>
+                  </a:txBody>
+                  <a:tcPr marL="137160" marR="137160" marT="73152" marB="73152" anchor="ctr"/>
+                </a:tc>
+              </a:tr>
+              <a:tr h="402336">
+                <a:tc>
+                  <a:txBody>
+                    <a:bodyPr/>
+                    <a:lstStyle/>
+                    <a:p>
+                      <a:endParaRPr lang="en-US" sz="1400" dirty="0"/>
+                    </a:p>
+                  </a:txBody>
+                  <a:tcPr marL="137160" marR="137160" marT="73152" marB="73152" anchor="ctr"/>
+                </a:tc>
+                <a:tc>
+                  <a:txBody>
+                    <a:bodyPr/>
+                    <a:lstStyle/>
+                    <a:p>
+                      <a:endParaRPr lang="en-US" sz="1400" dirty="0"/>
+                    </a:p>
+                  </a:txBody>
+                  <a:tcPr marL="137160" marR="137160" marT="73152" marB="73152" anchor="ctr"/>
+                </a:tc>
+                <a:tc>
+                  <a:txBody>
+                    <a:bodyPr/>
+                    <a:lstStyle/>
+                    <a:p>
+                      <a:endParaRPr lang="en-US" sz="1400" dirty="0"/>
+                    </a:p>
+                  </a:txBody>
+                  <a:tcPr marL="137160" marR="137160" marT="73152" marB="73152" anchor="ctr"/>
+                </a:tc>
+                <a:tc>
+                  <a:txBody>
+                    <a:bodyPr/>
+                    <a:lstStyle/>
+                    <a:p>
+                      <a:endParaRPr lang="en-US" sz="1400" dirty="0"/>
+                    </a:p>
+                  </a:txBody>
+                  <a:tcPr marL="137160" marR="137160" marT="73152" marB="73152" anchor="ctr"/>
+                </a:tc>
+                <a:tc>
+                  <a:txBody>
+                    <a:bodyPr/>
+                    <a:lstStyle/>
+                    <a:p>
+                      <a:endParaRPr lang="en-US" sz="1400" dirty="0"/>
+                    </a:p>
+                  </a:txBody>
+                  <a:tcPr marL="137160" marR="137160" marT="73152" marB="73152" anchor="ctr"/>
+                </a:tc>
+              </a:tr>
+              <a:tr h="402336">
+                <a:tc>
+                  <a:txBody>
+                    <a:bodyPr/>
+                    <a:lstStyle/>
+                    <a:p>
+                      <a:endParaRPr lang="en-US" sz="1400" dirty="0"/>
+                    </a:p>
+                  </a:txBody>
+                  <a:tcPr marL="137160" marR="137160" marT="73152" marB="73152" anchor="ctr"/>
+                </a:tc>
+                <a:tc>
+                  <a:txBody>
+                    <a:bodyPr/>
+                    <a:lstStyle/>
+                    <a:p>
+                      <a:endParaRPr lang="en-US" sz="1400" dirty="0"/>
+                    </a:p>
+                  </a:txBody>
+                  <a:tcPr marL="137160" marR="137160" marT="73152" marB="73152" anchor="ctr"/>
+                </a:tc>
+                <a:tc>
+                  <a:txBody>
+                    <a:bodyPr/>
+                    <a:lstStyle/>
+                    <a:p>
+                      <a:endParaRPr lang="en-US" sz="1400" dirty="0"/>
+                    </a:p>
+                  </a:txBody>
+                  <a:tcPr marL="137160" marR="137160" marT="73152" marB="73152" anchor="ctr"/>
+                </a:tc>
+                <a:tc>
+                  <a:txBody>
+                    <a:bodyPr/>
+                    <a:lstStyle/>
+                    <a:p>
+                      <a:endParaRPr lang="en-US" sz="1400" dirty="0"/>
+                    </a:p>
+                  </a:txBody>
+                  <a:tcPr marL="137160" marR="137160" marT="73152" marB="73152" anchor="ctr"/>
+                </a:tc>
+                <a:tc>
+                  <a:txBody>
+                    <a:bodyPr/>
+                    <a:lstStyle/>
+                    <a:p>
+                      <a:endParaRPr lang="en-US" sz="1400" dirty="0"/>
+                    </a:p>
+                  </a:txBody>
+                  <a:tcPr marL="137160" marR="137160" marT="73152" marB="73152" anchor="ctr"/>
+                </a:tc>
+              </a:tr>
+              <a:tr h="402336">
+                <a:tc>
+                  <a:txBody>
+                    <a:bodyPr/>
+                    <a:lstStyle/>
+                    <a:p>
+                      <a:endParaRPr lang="en-US" sz="1400" dirty="0"/>
+                    </a:p>
+                  </a:txBody>
+                  <a:tcPr marL="137160" marR="137160" marT="73152" marB="73152" anchor="ctr"/>
+                </a:tc>
+                <a:tc>
+                  <a:txBody>
+                    <a:bodyPr/>
+                    <a:lstStyle/>
+                    <a:p>
+                      <a:endParaRPr lang="en-US" sz="1400" dirty="0"/>
+                    </a:p>
+                  </a:txBody>
+                  <a:tcPr marL="137160" marR="137160" marT="73152" marB="73152" anchor="ctr"/>
+                </a:tc>
+                <a:tc>
+                  <a:txBody>
+                    <a:bodyPr/>
+                    <a:lstStyle/>
+                    <a:p>
+                      <a:endParaRPr lang="en-US" sz="1400" dirty="0"/>
+                    </a:p>
+                  </a:txBody>
+                  <a:tcPr marL="137160" marR="137160" marT="73152" marB="73152" anchor="ctr"/>
+                </a:tc>
+                <a:tc>
+                  <a:txBody>
+                    <a:bodyPr/>
+                    <a:lstStyle/>
+                    <a:p>
+                      <a:endParaRPr lang="en-US" sz="1400" dirty="0"/>
+                    </a:p>
+                  </a:txBody>
+                  <a:tcPr marL="137160" marR="137160" marT="73152" marB="73152" anchor="ctr"/>
+                </a:tc>
+                <a:tc>
+                  <a:txBody>
+                    <a:bodyPr/>
+                    <a:lstStyle/>
+                    <a:p>
+                      <a:endParaRPr lang="en-US" sz="1400" dirty="0"/>
+                    </a:p>
+                  </a:txBody>
+                  <a:tcPr marL="137160" marR="137160" marT="73152" marB="73152" anchor="ctr"/>
                 </a:tc>
               </a:tr>
             </a:tbl>

</xml_diff>

<commit_message>
feat(#2679): rework the built-in deck so every kind reads as its slide
Agenda as seven grouped (number, heading) entries; section number and
subtitle named; timeline dates inside each milestone; a 5-column, 8-row
table; statements read as quotes; column, step and picture fields short
enough to join their item; takeaway cards drawn as the zone's own fill;
notes set the kind of the light and picture covers, the dark flow, Code
and Big Number. Colours, fonts and pictures unchanged.

Test expectations follow the deck: 5 columns, a 16-row continuation and
the 6-column refusal. The secrets baseline takes the new template digest.
</commit_message>
<xml_diff>
--- a/libs/capabilities/fred-capability-ppt-filler/fred_capability_ppt_filler/builder/assets/fred_template.pptx
+++ b/libs/capabilities/fred-capability-ppt-filler/fred_capability_ppt_filler/builder/assets/fred_template.pptx
@@ -2021,8 +2021,21 @@
           <a:bodyPr/>
           <a:lstStyle/>
           <a:p>
-            <a:r>
-              <a:t>Layout: Fred Statement. One big message, light. statement up to ~110 characters; body optional, up to ~180 characters.</a:t>
+            <a:pPr/>
+            <a:r>
+              <a:t>kind: quote</a:t>
+            </a:r>
+          </a:p>
+          <a:p>
+            <a:pPr/>
+            <a:r>
+              <a:t>label: Statement</a:t>
+            </a:r>
+          </a:p>
+          <a:p>
+            <a:pPr/>
+            <a:r>
+              <a:t>One strong message up to ~110 characters, and its source or a supporting sentence under it.</a:t>
             </a:r>
           </a:p>
         </p:txBody>
@@ -2091,8 +2104,21 @@
           <a:bodyPr/>
           <a:lstStyle/>
           <a:p>
-            <a:r>
-              <a:t>Layout: Fred Statement Accent. One big message in the brand colour, for the key conclusion of a deck. Same placeholders as Fred Statement.</a:t>
+            <a:pPr/>
+            <a:r>
+              <a:t>kind: quote</a:t>
+            </a:r>
+          </a:p>
+          <a:p>
+            <a:pPr/>
+            <a:r>
+              <a:t>label: Statement, accent colour</a:t>
+            </a:r>
+          </a:p>
+          <a:p>
+            <a:pPr/>
+            <a:r>
+              <a:t>One strong message up to ~110 characters, and its source or a supporting sentence under it.</a:t>
             </a:r>
           </a:p>
         </p:txBody>
@@ -2371,8 +2397,9 @@
           <a:bodyPr/>
           <a:lstStyle/>
           <a:p>
-            <a:r>
-              <a:t>Layout: Fred Agenda. Agenda. body holds 3 to 7 items, one paragraph each, one line each (~45 characters); numbering is automatic.</a:t>
+            <a:pPr/>
+            <a:r>
+              <a:t>Layout: Fred Agenda. Up to 7 entries, each a two-digit number and a heading of up to ~45 characters; unused entries are removed.</a:t>
             </a:r>
           </a:p>
         </p:txBody>
@@ -3001,8 +3028,21 @@
           <a:bodyPr/>
           <a:lstStyle/>
           <a:p>
-            <a:r>
-              <a:t>Layout: Fred Big Number. One hero number with its meaning and 2 to 4 context bullets. Value at most 4 characters; label up to ~60 characters.</a:t>
+            <a:pPr/>
+            <a:r>
+              <a:t>kind: other</a:t>
+            </a:r>
+          </a:p>
+          <a:p>
+            <a:pPr/>
+            <a:r>
+              <a:t>label: Big number</a:t>
+            </a:r>
+          </a:p>
+          <a:p>
+            <a:pPr/>
+            <a:r>
+              <a:t>One hero number, what it means, and 2 to 4 context bullets. Set aside: the analysis does not read a lone figure beside other text as a one-item figures slide.</a:t>
             </a:r>
           </a:p>
         </p:txBody>
@@ -3421,8 +3461,9 @@
           <a:bodyPr/>
           <a:lstStyle/>
           <a:p>
-            <a:r>
-              <a:t>Layout: Fred Table. Native table. Up to ~8 rows and 5 columns; header row in the brand colour (default table style). Split larger tables across slides.</a:t>
+            <a:pPr/>
+            <a:r>
+              <a:t>Layout: Fred Table. Native table, up to 5 columns and 8 rows under the header; the table style colours the header, a total row and highlighted rows. Split larger tables across slides.</a:t>
             </a:r>
           </a:p>
         </p:txBody>
@@ -3701,8 +3742,9 @@
           <a:bodyPr/>
           <a:lstStyle/>
           <a:p>
-            <a:r>
-              <a:t>Layout: Fred Timeline. Roadmap of 5 milestones; the last dot is highlighted. Dates up to ~10 characters; titles 1 to 4 words; bodies up to ~90 characters. Delete unused milestone placeholders for fewer.</a:t>
+            <a:pPr/>
+            <a:r>
+              <a:t>Layout: Fred Timeline. Up to 5 milestones, each a date (year or quarter, up to ~10 characters), a title of 1 to 4 words and a body up to ~90 characters; unused milestones and their dots are removed.</a:t>
             </a:r>
           </a:p>
         </p:txBody>
@@ -3911,8 +3953,21 @@
           <a:bodyPr/>
           <a:lstStyle/>
           <a:p>
-            <a:r>
-              <a:t>Layout: Fred Title Image. Opening slide with a hero visual on the right. Image is cropped to about 9:10; product shots, illustrations or photos. Same text rules as Fred Title.</a:t>
+            <a:pPr/>
+            <a:r>
+              <a:t>kind: cover</a:t>
+            </a:r>
+          </a:p>
+          <a:p>
+            <a:pPr/>
+            <a:r>
+              <a:t>label: Cover with picture</a:t>
+            </a:r>
+          </a:p>
+          <a:p>
+            <a:pPr/>
+            <a:r>
+              <a:t>Cover with a picture on the right; use it when the deck has a hero image.</a:t>
             </a:r>
           </a:p>
         </p:txBody>
@@ -3981,8 +4036,15 @@
           <a:bodyPr/>
           <a:lstStyle/>
           <a:p>
-            <a:r>
-              <a:t>Layout: Fred Code. Code snippet in a dark editor panel (Courier New 14 pt, ~14 lines of ≤ 60 characters) with an explanation on the left. Keep indentation with spaces.</a:t>
+            <a:pPr/>
+            <a:r>
+              <a:t>kind: other</a:t>
+            </a:r>
+          </a:p>
+          <a:p>
+            <a:pPr/>
+            <a:r>
+              <a:t>Code sample for developer decks: the agent does not write code slides.</a:t>
             </a:r>
           </a:p>
         </p:txBody>
@@ -4051,8 +4113,21 @@
           <a:bodyPr/>
           <a:lstStyle/>
           <a:p>
-            <a:r>
-              <a:t>Layout: Fred Title Only Dark. Dark free composition, for architecture diagrams or demos. Same rules as Fred Title Only, with light shapes on navy. Showcase: compose light shapes on navy, as the sample below.</a:t>
+            <a:pPr/>
+            <a:r>
+              <a:t>kind: process</a:t>
+            </a:r>
+          </a:p>
+          <a:p>
+            <a:pPr/>
+            <a:r>
+              <a:t>label: Four-step flow, short labels</a:t>
+            </a:r>
+          </a:p>
+          <a:p>
+            <a:pPr/>
+            <a:r>
+              <a:t>Dark canvas: up to 4 steps of 1 to 3 words each, joined by arrows.</a:t>
             </a:r>
           </a:p>
         </p:txBody>
@@ -4401,8 +4476,21 @@
           <a:bodyPr/>
           <a:lstStyle/>
           <a:p>
-            <a:r>
-              <a:t>Layout: Fred Title Light. Opening slide, light variant for printed or document-style decks. Same placeholders as Fred Title.</a:t>
+            <a:pPr/>
+            <a:r>
+              <a:t>kind: cover</a:t>
+            </a:r>
+          </a:p>
+          <a:p>
+            <a:pPr/>
+            <a:r>
+              <a:t>label: Cover, light</a:t>
+            </a:r>
+          </a:p>
+          <a:p>
+            <a:pPr/>
+            <a:r>
+              <a:t>Light cover for document-style and printed decks.</a:t>
             </a:r>
           </a:p>
         </p:txBody>
@@ -5882,7 +5970,7 @@
         <p:spPr>
           <a:xfrm>
             <a:off x="548640" y="3017520"/>
-            <a:ext cx="3393338" cy="3017520"/>
+            <a:ext cx="3393338" cy="2743200"/>
           </a:xfrm>
           <a:prstGeom prst="rect">
             <a:avLst/>
@@ -6046,7 +6134,7 @@
         <p:spPr>
           <a:xfrm>
             <a:off x="4399178" y="3017520"/>
-            <a:ext cx="3393338" cy="3017520"/>
+            <a:ext cx="3393338" cy="2743200"/>
           </a:xfrm>
           <a:prstGeom prst="rect">
             <a:avLst/>
@@ -6210,7 +6298,7 @@
         <p:spPr>
           <a:xfrm>
             <a:off x="8249717" y="3017520"/>
-            <a:ext cx="3393338" cy="3017520"/>
+            <a:ext cx="3393338" cy="2743200"/>
           </a:xfrm>
           <a:prstGeom prst="rect">
             <a:avLst/>
@@ -13181,7 +13269,7 @@
         <p:spPr>
           <a:xfrm>
             <a:off x="548640" y="1691640"/>
-            <a:ext cx="3484778" cy="3017520"/>
+            <a:ext cx="3484778" cy="2743200"/>
           </a:xfrm>
           <a:prstGeom prst="roundRect">
             <a:avLst>
@@ -13216,7 +13304,7 @@
         <p:spPr>
           <a:xfrm>
             <a:off x="548640" y="1691640"/>
-            <a:ext cx="3484778" cy="3017520"/>
+            <a:ext cx="3484778" cy="2743200"/>
           </a:xfrm>
           <a:prstGeom prst="roundRect">
             <a:avLst>
@@ -13257,7 +13345,7 @@
         </p:nvSpPr>
         <p:spPr>
           <a:xfrm>
-            <a:off x="548640" y="4892040"/>
+            <a:off x="548640" y="4617720"/>
             <a:ext cx="3484778" cy="365760"/>
           </a:xfrm>
           <a:prstGeom prst="rect">
@@ -13305,7 +13393,7 @@
         </p:nvSpPr>
         <p:spPr>
           <a:xfrm>
-            <a:off x="548640" y="5257800"/>
+            <a:off x="548640" y="4983480"/>
             <a:ext cx="3484778" cy="777240"/>
           </a:xfrm>
           <a:prstGeom prst="rect">
@@ -13353,7 +13441,7 @@
         <p:spPr>
           <a:xfrm>
             <a:off x="4353458" y="1691640"/>
-            <a:ext cx="3484778" cy="3017520"/>
+            <a:ext cx="3484778" cy="2743200"/>
           </a:xfrm>
           <a:prstGeom prst="roundRect">
             <a:avLst>
@@ -13388,7 +13476,7 @@
         <p:spPr>
           <a:xfrm>
             <a:off x="4353458" y="1691640"/>
-            <a:ext cx="3484778" cy="3017520"/>
+            <a:ext cx="3484778" cy="2743200"/>
           </a:xfrm>
           <a:prstGeom prst="roundRect">
             <a:avLst>
@@ -13429,7 +13517,7 @@
         </p:nvSpPr>
         <p:spPr>
           <a:xfrm>
-            <a:off x="4353458" y="4892040"/>
+            <a:off x="4353458" y="4617720"/>
             <a:ext cx="3484778" cy="365760"/>
           </a:xfrm>
           <a:prstGeom prst="rect">
@@ -13477,7 +13565,7 @@
         </p:nvSpPr>
         <p:spPr>
           <a:xfrm>
-            <a:off x="4353458" y="5257800"/>
+            <a:off x="4353458" y="4983480"/>
             <a:ext cx="3484778" cy="777240"/>
           </a:xfrm>
           <a:prstGeom prst="rect">
@@ -13525,7 +13613,7 @@
         <p:spPr>
           <a:xfrm>
             <a:off x="8158277" y="1691640"/>
-            <a:ext cx="3484778" cy="3017520"/>
+            <a:ext cx="3484778" cy="2743200"/>
           </a:xfrm>
           <a:prstGeom prst="roundRect">
             <a:avLst>
@@ -13560,7 +13648,7 @@
         <p:spPr>
           <a:xfrm>
             <a:off x="8158277" y="1691640"/>
-            <a:ext cx="3484778" cy="3017520"/>
+            <a:ext cx="3484778" cy="2743200"/>
           </a:xfrm>
           <a:prstGeom prst="roundRect">
             <a:avLst>
@@ -13601,7 +13689,7 @@
         </p:nvSpPr>
         <p:spPr>
           <a:xfrm>
-            <a:off x="8158277" y="4892040"/>
+            <a:off x="8158277" y="4617720"/>
             <a:ext cx="3484778" cy="365760"/>
           </a:xfrm>
           <a:prstGeom prst="rect">
@@ -13649,7 +13737,7 @@
         </p:nvSpPr>
         <p:spPr>
           <a:xfrm>
-            <a:off x="8158277" y="5257800"/>
+            <a:off x="8158277" y="4983480"/>
             <a:ext cx="3484778" cy="777240"/>
           </a:xfrm>
           <a:prstGeom prst="rect">
@@ -16647,88 +16735,26 @@
       </p:sp>
       <p:sp>
         <p:nvSpPr>
-          <p:cNvPr id="6" name="Card"/>
-          <p:cNvSpPr/>
-          <p:nvPr userDrawn="1"/>
+          <p:cNvPr id="8" name="takeaway"/>
+          <p:cNvSpPr>
+            <a:spLocks noGrp="1"/>
+          </p:cNvSpPr>
+          <p:nvPr>
+            <p:ph type="body" idx="103" hasCustomPrompt="1"/>
+          </p:nvPr>
         </p:nvSpPr>
         <p:spPr>
           <a:xfrm>
             <a:off x="8275320" y="1691640"/>
             <a:ext cx="3367735" cy="4343400"/>
           </a:xfrm>
-          <a:prstGeom prst="roundRect">
-            <a:avLst>
-              <a:gd name="adj" fmla="val 4344"/>
-            </a:avLst>
-          </a:prstGeom>
-          <a:solidFill>
-            <a:schemeClr val="bg2"/>
-          </a:solidFill>
-          <a:ln>
-            <a:noFill/>
-          </a:ln>
-        </p:spPr>
-        <p:txBody>
-          <a:bodyPr rtlCol="0" anchor="ctr"/>
-          <a:lstStyle/>
-          <a:p>
-            <a:endParaRPr lang="en-US"/>
-          </a:p>
-        </p:txBody>
-      </p:sp>
-      <p:sp>
-        <p:nvSpPr>
-          <p:cNvPr id="7" name="Tile"/>
-          <p:cNvSpPr/>
-          <p:nvPr userDrawn="1"/>
-        </p:nvSpPr>
-        <p:spPr>
-          <a:xfrm>
-            <a:off x="8595360" y="2057400"/>
-            <a:ext cx="237744" cy="237744"/>
-          </a:xfrm>
-          <a:prstGeom prst="roundRect">
-            <a:avLst>
-              <a:gd name="adj" fmla="val 13500"/>
-            </a:avLst>
-          </a:prstGeom>
-          <a:solidFill>
-            <a:schemeClr val="accent1"/>
-          </a:solidFill>
-          <a:ln>
-            <a:noFill/>
-          </a:ln>
-        </p:spPr>
-        <p:txBody>
-          <a:bodyPr rtlCol="0" anchor="ctr"/>
-          <a:lstStyle/>
-          <a:p>
-            <a:endParaRPr lang="en-US"/>
-          </a:p>
-        </p:txBody>
-      </p:sp>
-      <p:sp>
-        <p:nvSpPr>
-          <p:cNvPr id="8" name="takeaway"/>
-          <p:cNvSpPr>
-            <a:spLocks noGrp="1"/>
-          </p:cNvSpPr>
-          <p:nvPr>
-            <p:ph type="body" idx="103" hasCustomPrompt="1"/>
-          </p:nvPr>
-        </p:nvSpPr>
-        <p:spPr>
-          <a:xfrm>
-            <a:off x="8595360" y="2560320"/>
-            <a:ext cx="2743200" cy="3154680"/>
-          </a:xfrm>
           <a:prstGeom prst="rect">
             <a:avLst/>
           </a:prstGeom>
           <a:noFill/>
         </p:spPr>
         <p:txBody>
-          <a:bodyPr wrap="square" lIns="0" tIns="0" rIns="0" bIns="0" rtlCol="0" anchor="t">
+          <a:bodyPr wrap="square" lIns="320040" tIns="365760" rIns="304495" bIns="320040" rtlCol="0" anchor="t">
             <a:normAutofit/>
           </a:bodyPr>
           <a:lstStyle>
@@ -20453,7 +20479,7 @@
         <p:spPr>
           <a:xfrm>
             <a:off x="548640" y="2834640"/>
-            <a:ext cx="3210458" cy="3200400"/>
+            <a:ext cx="3210458" cy="2743200"/>
           </a:xfrm>
           <a:prstGeom prst="rect">
             <a:avLst/>
@@ -20604,7 +20630,7 @@
         <p:spPr>
           <a:xfrm>
             <a:off x="4444898" y="2834640"/>
-            <a:ext cx="3210458" cy="3200400"/>
+            <a:ext cx="3210458" cy="2743200"/>
           </a:xfrm>
           <a:prstGeom prst="rect">
             <a:avLst/>
@@ -20755,7 +20781,7 @@
         <p:spPr>
           <a:xfrm>
             <a:off x="8112557" y="2834640"/>
-            <a:ext cx="3210458" cy="3200400"/>
+            <a:ext cx="3210458" cy="2743200"/>
           </a:xfrm>
           <a:prstGeom prst="rect">
             <a:avLst/>
@@ -21147,7 +21173,7 @@
         </p:nvSpPr>
         <p:spPr>
           <a:xfrm>
-            <a:off x="548640" y="1920240"/>
+            <a:off x="548640" y="2057400"/>
             <a:ext cx="1944563" cy="411480"/>
           </a:xfrm>
           <a:prstGeom prst="rect">
@@ -21328,7 +21354,7 @@
         </p:nvSpPr>
         <p:spPr>
           <a:xfrm>
-            <a:off x="2767523" y="1920240"/>
+            <a:off x="2767523" y="2057400"/>
             <a:ext cx="1944563" cy="411480"/>
           </a:xfrm>
           <a:prstGeom prst="rect">
@@ -21509,7 +21535,7 @@
         </p:nvSpPr>
         <p:spPr>
           <a:xfrm>
-            <a:off x="4986406" y="1920240"/>
+            <a:off x="4986406" y="2057400"/>
             <a:ext cx="1944563" cy="411480"/>
           </a:xfrm>
           <a:prstGeom prst="rect">
@@ -21690,7 +21716,7 @@
         </p:nvSpPr>
         <p:spPr>
           <a:xfrm>
-            <a:off x="7205289" y="1920240"/>
+            <a:off x="7205289" y="2057400"/>
             <a:ext cx="1944563" cy="411480"/>
           </a:xfrm>
           <a:prstGeom prst="rect">
@@ -21871,7 +21897,7 @@
         </p:nvSpPr>
         <p:spPr>
           <a:xfrm>
-            <a:off x="9424172" y="1920240"/>
+            <a:off x="9424172" y="2057400"/>
             <a:ext cx="1944563" cy="411480"/>
           </a:xfrm>
           <a:prstGeom prst="rect">
@@ -22886,88 +22912,26 @@
       </p:sp>
       <p:sp>
         <p:nvSpPr>
-          <p:cNvPr id="19" name="Card"/>
-          <p:cNvSpPr/>
-          <p:nvPr userDrawn="1"/>
+          <p:cNvPr id="21" name="takeaway"/>
+          <p:cNvSpPr>
+            <a:spLocks noGrp="1"/>
+          </p:cNvSpPr>
+          <p:nvPr>
+            <p:ph type="body" idx="111" hasCustomPrompt="1"/>
+          </p:nvPr>
         </p:nvSpPr>
         <p:spPr>
           <a:xfrm>
             <a:off x="8458200" y="1691640"/>
             <a:ext cx="3184855" cy="4343400"/>
           </a:xfrm>
-          <a:prstGeom prst="roundRect">
-            <a:avLst>
-              <a:gd name="adj" fmla="val 4593"/>
-            </a:avLst>
-          </a:prstGeom>
-          <a:solidFill>
-            <a:schemeClr val="bg2"/>
-          </a:solidFill>
-          <a:ln>
-            <a:noFill/>
-          </a:ln>
-        </p:spPr>
-        <p:txBody>
-          <a:bodyPr rtlCol="0" anchor="ctr"/>
-          <a:lstStyle/>
-          <a:p>
-            <a:endParaRPr lang="en-US"/>
-          </a:p>
-        </p:txBody>
-      </p:sp>
-      <p:sp>
-        <p:nvSpPr>
-          <p:cNvPr id="20" name="Tile"/>
-          <p:cNvSpPr/>
-          <p:nvPr userDrawn="1"/>
-        </p:nvSpPr>
-        <p:spPr>
-          <a:xfrm>
-            <a:off x="8778240" y="2057400"/>
-            <a:ext cx="237744" cy="237744"/>
-          </a:xfrm>
-          <a:prstGeom prst="roundRect">
-            <a:avLst>
-              <a:gd name="adj" fmla="val 13500"/>
-            </a:avLst>
-          </a:prstGeom>
-          <a:solidFill>
-            <a:schemeClr val="accent1"/>
-          </a:solidFill>
-          <a:ln>
-            <a:noFill/>
-          </a:ln>
-        </p:spPr>
-        <p:txBody>
-          <a:bodyPr rtlCol="0" anchor="ctr"/>
-          <a:lstStyle/>
-          <a:p>
-            <a:endParaRPr lang="en-US"/>
-          </a:p>
-        </p:txBody>
-      </p:sp>
-      <p:sp>
-        <p:nvSpPr>
-          <p:cNvPr id="21" name="takeaway"/>
-          <p:cNvSpPr>
-            <a:spLocks noGrp="1"/>
-          </p:cNvSpPr>
-          <p:nvPr>
-            <p:ph type="body" idx="111" hasCustomPrompt="1"/>
-          </p:nvPr>
-        </p:nvSpPr>
-        <p:spPr>
-          <a:xfrm>
-            <a:off x="8778240" y="2560320"/>
-            <a:ext cx="2560320" cy="3154680"/>
-          </a:xfrm>
           <a:prstGeom prst="rect">
             <a:avLst/>
           </a:prstGeom>
           <a:noFill/>
         </p:spPr>
         <p:txBody>
-          <a:bodyPr wrap="square" lIns="0" tIns="0" rIns="0" bIns="0" rtlCol="0" anchor="t">
+          <a:bodyPr wrap="square" lIns="320040" tIns="365760" rIns="304495" bIns="320040" rtlCol="0" anchor="t">
             <a:normAutofit/>
           </a:bodyPr>
           <a:lstStyle>
@@ -24875,62 +24839,6 @@
             <a:r>
               <a:rPr lang="en-US" dirty="0"/>
               <a:t>Agenda</a:t>
-            </a:r>
-          </a:p>
-        </p:txBody>
-      </p:sp>
-      <p:sp>
-        <p:nvSpPr>
-          <p:cNvPr id="11" name="body"/>
-          <p:cNvSpPr>
-            <a:spLocks noGrp="1"/>
-          </p:cNvSpPr>
-          <p:nvPr>
-            <p:ph type="body" idx="102" hasCustomPrompt="1"/>
-          </p:nvPr>
-        </p:nvSpPr>
-        <p:spPr>
-          <a:xfrm>
-            <a:off x="4846320" y="868680"/>
-            <a:ext cx="6793992" cy="5120640"/>
-          </a:xfrm>
-          <a:prstGeom prst="rect">
-            <a:avLst/>
-          </a:prstGeom>
-          <a:noFill/>
-        </p:spPr>
-        <p:txBody>
-          <a:bodyPr wrap="square" lIns="0" tIns="0" rIns="0" bIns="0" rtlCol="0" anchor="t">
-            <a:normAutofit/>
-          </a:bodyPr>
-          <a:lstStyle>
-            <a:lvl1pPr marL="502920" indent="-502920" algn="l">
-              <a:lnSpc>
-                <a:spcPct val="105000"/>
-              </a:lnSpc>
-              <a:spcBef>
-                <a:spcPts val="0"/>
-              </a:spcBef>
-              <a:spcAft>
-                <a:spcPts val="1600"/>
-              </a:spcAft>
-              <a:buClr>
-                <a:schemeClr val="accent1"/>
-              </a:buClr>
-              <a:buSzPct val="100000"/>
-              <a:buFont typeface="+mj-lt"/>
-              <a:buAutoNum type="arabicPeriod"/>
-              <a:defRPr sz="2000" b="0" dirty="0">
-                <a:solidFill>
-                  <a:schemeClr val="tx1"/>
-                </a:solidFill>
-              </a:defRPr>
-            </a:lvl1pPr>
-          </a:lstStyle>
-          <a:p>
-            <a:r>
-              <a:rPr lang="en-US" dirty="0"/>
-              <a:t>Agenda item</a:t>
             </a:r>
           </a:p>
         </p:txBody>
@@ -30587,7 +30495,7 @@
       </p:sp>
       <p:sp>
         <p:nvSpPr>
-          <p:cNvPr id="3" name="Text Placeholder 2"/>
+          <p:cNvPr id="3" name="title"/>
           <p:cNvSpPr>
             <a:spLocks noGrp="1"/>
           </p:cNvSpPr>
@@ -30609,7 +30517,7 @@
       </p:sp>
       <p:sp>
         <p:nvSpPr>
-          <p:cNvPr id="4" name="Text Placeholder 3"/>
+          <p:cNvPr id="4" name="subtitle"/>
           <p:cNvSpPr>
             <a:spLocks noGrp="1"/>
           </p:cNvSpPr>
@@ -30671,7 +30579,7 @@
       </p:sp>
       <p:sp>
         <p:nvSpPr>
-          <p:cNvPr id="3" name="Text Placeholder 2"/>
+          <p:cNvPr id="3" name="title"/>
           <p:cNvSpPr>
             <a:spLocks noGrp="1"/>
           </p:cNvSpPr>
@@ -30693,7 +30601,7 @@
       </p:sp>
       <p:sp>
         <p:nvSpPr>
-          <p:cNvPr id="4" name="Text Placeholder 3"/>
+          <p:cNvPr id="4" name="subtitle"/>
           <p:cNvSpPr>
             <a:spLocks noGrp="1"/>
           </p:cNvSpPr>
@@ -30895,7 +30803,7 @@
       </p:pic>
       <p:sp>
         <p:nvSpPr>
-          <p:cNvPr id="3" name="Text Placeholder 2"/>
+          <p:cNvPr id="3" name="number"/>
           <p:cNvSpPr>
             <a:spLocks noGrp="1"/>
           </p:cNvSpPr>
@@ -30939,7 +30847,7 @@
       </p:sp>
       <p:sp>
         <p:nvSpPr>
-          <p:cNvPr id="5" name="Text Placeholder 4"/>
+          <p:cNvPr id="5" name="subtitle"/>
           <p:cNvSpPr>
             <a:spLocks noGrp="1"/>
           </p:cNvSpPr>
@@ -31021,64 +30929,615 @@
           </a:p>
         </p:txBody>
       </p:sp>
-      <p:sp>
-        <p:nvSpPr>
-          <p:cNvPr id="4" name="Text Placeholder 3"/>
-          <p:cNvSpPr>
-            <a:spLocks noGrp="1"/>
-          </p:cNvSpPr>
-          <p:nvPr>
-            <p:ph type="body" idx="102"/>
-          </p:nvPr>
-        </p:nvSpPr>
-        <p:spPr/>
-        <p:txBody>
-          <a:bodyPr/>
-          <a:lstStyle/>
-          <a:p>
-            <a:pPr/>
-            <a:r>
-              <a:t>Design principles</a:t>
-            </a:r>
-          </a:p>
-          <a:p>
-            <a:pPr/>
-            <a:r>
-              <a:t>Openings and sections</a:t>
-            </a:r>
-          </a:p>
-          <a:p>
-            <a:pPr/>
-            <a:r>
-              <a:t>Text and comparison layouts</a:t>
-            </a:r>
-          </a:p>
-          <a:p>
-            <a:pPr/>
-            <a:r>
-              <a:t>Visual layouts</a:t>
-            </a:r>
-          </a:p>
-          <a:p>
-            <a:pPr/>
-            <a:r>
-              <a:t>Data layouts</a:t>
-            </a:r>
-          </a:p>
-          <a:p>
-            <a:pPr/>
-            <a:r>
-              <a:t>Process, people and code</a:t>
-            </a:r>
-          </a:p>
-          <a:p>
-            <a:pPr/>
-            <a:r>
-              <a:t>Closings and free canvases</a:t>
-            </a:r>
-          </a:p>
-        </p:txBody>
-      </p:sp>
+      <p:grpSp>
+        <p:nvGrpSpPr>
+          <p:cNvPr id="6" name="Agenda entry 1"/>
+          <p:cNvGrpSpPr/>
+          <p:nvPr/>
+        </p:nvGrpSpPr>
+        <p:grpSpPr>
+          <a:xfrm>
+            <a:off x="4846320" y="868680"/>
+            <a:ext cx="6793992" cy="457200"/>
+            <a:chOff x="4846320" y="868680"/>
+            <a:chExt cx="6793992" cy="457200"/>
+          </a:xfrm>
+        </p:grpSpPr>
+        <p:sp>
+          <p:nvSpPr>
+            <p:cNvPr id="4" name="number"/>
+            <p:cNvSpPr txBox="1"/>
+            <p:nvPr/>
+          </p:nvSpPr>
+          <p:spPr>
+            <a:xfrm>
+              <a:off x="4846320" y="868680"/>
+              <a:ext cx="640080" cy="457200"/>
+            </a:xfrm>
+            <a:prstGeom prst="rect">
+              <a:avLst/>
+            </a:prstGeom>
+            <a:noFill/>
+          </p:spPr>
+          <p:txBody>
+            <a:bodyPr wrap="square" lIns="0" tIns="0" rIns="0" bIns="0" rtlCol="0" anchor="ctr">
+              <a:normAutofit/>
+            </a:bodyPr>
+            <a:lstStyle/>
+            <a:p>
+              <a:pPr marL="0" indent="0" algn="l">
+                <a:buNone/>
+              </a:pPr>
+              <a:r>
+                <a:rPr lang="en-US" sz="2000" b="1" dirty="0">
+                  <a:solidFill>
+                    <a:schemeClr val="accent1"/>
+                  </a:solidFill>
+                </a:rPr>
+                <a:t>01</a:t>
+              </a:r>
+            </a:p>
+          </p:txBody>
+        </p:sp>
+        <p:sp>
+          <p:nvSpPr>
+            <p:cNvPr id="5" name="heading"/>
+            <p:cNvSpPr txBox="1"/>
+            <p:nvPr/>
+          </p:nvSpPr>
+          <p:spPr>
+            <a:xfrm>
+              <a:off x="5577840" y="868680"/>
+              <a:ext cx="6062472" cy="457200"/>
+            </a:xfrm>
+            <a:prstGeom prst="rect">
+              <a:avLst/>
+            </a:prstGeom>
+            <a:noFill/>
+          </p:spPr>
+          <p:txBody>
+            <a:bodyPr wrap="square" lIns="0" tIns="0" rIns="0" bIns="0" rtlCol="0" anchor="ctr">
+              <a:normAutofit/>
+            </a:bodyPr>
+            <a:lstStyle/>
+            <a:p>
+              <a:pPr marL="0" indent="0" algn="l">
+                <a:buNone/>
+              </a:pPr>
+              <a:r>
+                <a:rPr lang="en-US" sz="2000" b="0" dirty="0">
+                  <a:solidFill>
+                    <a:schemeClr val="tx1"/>
+                  </a:solidFill>
+                </a:rPr>
+                <a:t>Design principles</a:t>
+              </a:r>
+            </a:p>
+          </p:txBody>
+        </p:sp>
+      </p:grpSp>
+      <p:grpSp>
+        <p:nvGrpSpPr>
+          <p:cNvPr id="9" name="Agenda entry 2"/>
+          <p:cNvGrpSpPr/>
+          <p:nvPr/>
+        </p:nvGrpSpPr>
+        <p:grpSpPr>
+          <a:xfrm>
+            <a:off x="4846320" y="1600200"/>
+            <a:ext cx="6793992" cy="457200"/>
+            <a:chOff x="4846320" y="1600200"/>
+            <a:chExt cx="6793992" cy="457200"/>
+          </a:xfrm>
+        </p:grpSpPr>
+        <p:sp>
+          <p:nvSpPr>
+            <p:cNvPr id="7" name="number"/>
+            <p:cNvSpPr txBox="1"/>
+            <p:nvPr/>
+          </p:nvSpPr>
+          <p:spPr>
+            <a:xfrm>
+              <a:off x="4846320" y="1600200"/>
+              <a:ext cx="640080" cy="457200"/>
+            </a:xfrm>
+            <a:prstGeom prst="rect">
+              <a:avLst/>
+            </a:prstGeom>
+            <a:noFill/>
+          </p:spPr>
+          <p:txBody>
+            <a:bodyPr wrap="square" lIns="0" tIns="0" rIns="0" bIns="0" rtlCol="0" anchor="ctr">
+              <a:normAutofit/>
+            </a:bodyPr>
+            <a:lstStyle/>
+            <a:p>
+              <a:pPr marL="0" indent="0" algn="l">
+                <a:buNone/>
+              </a:pPr>
+              <a:r>
+                <a:rPr lang="en-US" sz="2000" b="1" dirty="0">
+                  <a:solidFill>
+                    <a:schemeClr val="accent1"/>
+                  </a:solidFill>
+                </a:rPr>
+                <a:t>02</a:t>
+              </a:r>
+            </a:p>
+          </p:txBody>
+        </p:sp>
+        <p:sp>
+          <p:nvSpPr>
+            <p:cNvPr id="8" name="heading"/>
+            <p:cNvSpPr txBox="1"/>
+            <p:nvPr/>
+          </p:nvSpPr>
+          <p:spPr>
+            <a:xfrm>
+              <a:off x="5577840" y="1600200"/>
+              <a:ext cx="6062472" cy="457200"/>
+            </a:xfrm>
+            <a:prstGeom prst="rect">
+              <a:avLst/>
+            </a:prstGeom>
+            <a:noFill/>
+          </p:spPr>
+          <p:txBody>
+            <a:bodyPr wrap="square" lIns="0" tIns="0" rIns="0" bIns="0" rtlCol="0" anchor="ctr">
+              <a:normAutofit/>
+            </a:bodyPr>
+            <a:lstStyle/>
+            <a:p>
+              <a:pPr marL="0" indent="0" algn="l">
+                <a:buNone/>
+              </a:pPr>
+              <a:r>
+                <a:rPr lang="en-US" sz="2000" b="0" dirty="0">
+                  <a:solidFill>
+                    <a:schemeClr val="tx1"/>
+                  </a:solidFill>
+                </a:rPr>
+                <a:t>Openings and sections</a:t>
+              </a:r>
+            </a:p>
+          </p:txBody>
+        </p:sp>
+      </p:grpSp>
+      <p:grpSp>
+        <p:nvGrpSpPr>
+          <p:cNvPr id="12" name="Agenda entry 3"/>
+          <p:cNvGrpSpPr/>
+          <p:nvPr/>
+        </p:nvGrpSpPr>
+        <p:grpSpPr>
+          <a:xfrm>
+            <a:off x="4846320" y="2331720"/>
+            <a:ext cx="6793992" cy="457200"/>
+            <a:chOff x="4846320" y="2331720"/>
+            <a:chExt cx="6793992" cy="457200"/>
+          </a:xfrm>
+        </p:grpSpPr>
+        <p:sp>
+          <p:nvSpPr>
+            <p:cNvPr id="10" name="number"/>
+            <p:cNvSpPr txBox="1"/>
+            <p:nvPr/>
+          </p:nvSpPr>
+          <p:spPr>
+            <a:xfrm>
+              <a:off x="4846320" y="2331720"/>
+              <a:ext cx="640080" cy="457200"/>
+            </a:xfrm>
+            <a:prstGeom prst="rect">
+              <a:avLst/>
+            </a:prstGeom>
+            <a:noFill/>
+          </p:spPr>
+          <p:txBody>
+            <a:bodyPr wrap="square" lIns="0" tIns="0" rIns="0" bIns="0" rtlCol="0" anchor="ctr">
+              <a:normAutofit/>
+            </a:bodyPr>
+            <a:lstStyle/>
+            <a:p>
+              <a:pPr marL="0" indent="0" algn="l">
+                <a:buNone/>
+              </a:pPr>
+              <a:r>
+                <a:rPr lang="en-US" sz="2000" b="1" dirty="0">
+                  <a:solidFill>
+                    <a:schemeClr val="accent1"/>
+                  </a:solidFill>
+                </a:rPr>
+                <a:t>03</a:t>
+              </a:r>
+            </a:p>
+          </p:txBody>
+        </p:sp>
+        <p:sp>
+          <p:nvSpPr>
+            <p:cNvPr id="11" name="heading"/>
+            <p:cNvSpPr txBox="1"/>
+            <p:nvPr/>
+          </p:nvSpPr>
+          <p:spPr>
+            <a:xfrm>
+              <a:off x="5577840" y="2331720"/>
+              <a:ext cx="6062472" cy="457200"/>
+            </a:xfrm>
+            <a:prstGeom prst="rect">
+              <a:avLst/>
+            </a:prstGeom>
+            <a:noFill/>
+          </p:spPr>
+          <p:txBody>
+            <a:bodyPr wrap="square" lIns="0" tIns="0" rIns="0" bIns="0" rtlCol="0" anchor="ctr">
+              <a:normAutofit/>
+            </a:bodyPr>
+            <a:lstStyle/>
+            <a:p>
+              <a:pPr marL="0" indent="0" algn="l">
+                <a:buNone/>
+              </a:pPr>
+              <a:r>
+                <a:rPr lang="en-US" sz="2000" b="0" dirty="0">
+                  <a:solidFill>
+                    <a:schemeClr val="tx1"/>
+                  </a:solidFill>
+                </a:rPr>
+                <a:t>Text and comparison layouts</a:t>
+              </a:r>
+            </a:p>
+          </p:txBody>
+        </p:sp>
+      </p:grpSp>
+      <p:grpSp>
+        <p:nvGrpSpPr>
+          <p:cNvPr id="15" name="Agenda entry 4"/>
+          <p:cNvGrpSpPr/>
+          <p:nvPr/>
+        </p:nvGrpSpPr>
+        <p:grpSpPr>
+          <a:xfrm>
+            <a:off x="4846320" y="3063240"/>
+            <a:ext cx="6793992" cy="457200"/>
+            <a:chOff x="4846320" y="3063240"/>
+            <a:chExt cx="6793992" cy="457200"/>
+          </a:xfrm>
+        </p:grpSpPr>
+        <p:sp>
+          <p:nvSpPr>
+            <p:cNvPr id="13" name="number"/>
+            <p:cNvSpPr txBox="1"/>
+            <p:nvPr/>
+          </p:nvSpPr>
+          <p:spPr>
+            <a:xfrm>
+              <a:off x="4846320" y="3063240"/>
+              <a:ext cx="640080" cy="457200"/>
+            </a:xfrm>
+            <a:prstGeom prst="rect">
+              <a:avLst/>
+            </a:prstGeom>
+            <a:noFill/>
+          </p:spPr>
+          <p:txBody>
+            <a:bodyPr wrap="square" lIns="0" tIns="0" rIns="0" bIns="0" rtlCol="0" anchor="ctr">
+              <a:normAutofit/>
+            </a:bodyPr>
+            <a:lstStyle/>
+            <a:p>
+              <a:pPr marL="0" indent="0" algn="l">
+                <a:buNone/>
+              </a:pPr>
+              <a:r>
+                <a:rPr lang="en-US" sz="2000" b="1" dirty="0">
+                  <a:solidFill>
+                    <a:schemeClr val="accent1"/>
+                  </a:solidFill>
+                </a:rPr>
+                <a:t>04</a:t>
+              </a:r>
+            </a:p>
+          </p:txBody>
+        </p:sp>
+        <p:sp>
+          <p:nvSpPr>
+            <p:cNvPr id="14" name="heading"/>
+            <p:cNvSpPr txBox="1"/>
+            <p:nvPr/>
+          </p:nvSpPr>
+          <p:spPr>
+            <a:xfrm>
+              <a:off x="5577840" y="3063240"/>
+              <a:ext cx="6062472" cy="457200"/>
+            </a:xfrm>
+            <a:prstGeom prst="rect">
+              <a:avLst/>
+            </a:prstGeom>
+            <a:noFill/>
+          </p:spPr>
+          <p:txBody>
+            <a:bodyPr wrap="square" lIns="0" tIns="0" rIns="0" bIns="0" rtlCol="0" anchor="ctr">
+              <a:normAutofit/>
+            </a:bodyPr>
+            <a:lstStyle/>
+            <a:p>
+              <a:pPr marL="0" indent="0" algn="l">
+                <a:buNone/>
+              </a:pPr>
+              <a:r>
+                <a:rPr lang="en-US" sz="2000" b="0" dirty="0">
+                  <a:solidFill>
+                    <a:schemeClr val="tx1"/>
+                  </a:solidFill>
+                </a:rPr>
+                <a:t>Visual layouts</a:t>
+              </a:r>
+            </a:p>
+          </p:txBody>
+        </p:sp>
+      </p:grpSp>
+      <p:grpSp>
+        <p:nvGrpSpPr>
+          <p:cNvPr id="18" name="Agenda entry 5"/>
+          <p:cNvGrpSpPr/>
+          <p:nvPr/>
+        </p:nvGrpSpPr>
+        <p:grpSpPr>
+          <a:xfrm>
+            <a:off x="4846320" y="3794760"/>
+            <a:ext cx="6793992" cy="457200"/>
+            <a:chOff x="4846320" y="3794760"/>
+            <a:chExt cx="6793992" cy="457200"/>
+          </a:xfrm>
+        </p:grpSpPr>
+        <p:sp>
+          <p:nvSpPr>
+            <p:cNvPr id="16" name="number"/>
+            <p:cNvSpPr txBox="1"/>
+            <p:nvPr/>
+          </p:nvSpPr>
+          <p:spPr>
+            <a:xfrm>
+              <a:off x="4846320" y="3794760"/>
+              <a:ext cx="640080" cy="457200"/>
+            </a:xfrm>
+            <a:prstGeom prst="rect">
+              <a:avLst/>
+            </a:prstGeom>
+            <a:noFill/>
+          </p:spPr>
+          <p:txBody>
+            <a:bodyPr wrap="square" lIns="0" tIns="0" rIns="0" bIns="0" rtlCol="0" anchor="ctr">
+              <a:normAutofit/>
+            </a:bodyPr>
+            <a:lstStyle/>
+            <a:p>
+              <a:pPr marL="0" indent="0" algn="l">
+                <a:buNone/>
+              </a:pPr>
+              <a:r>
+                <a:rPr lang="en-US" sz="2000" b="1" dirty="0">
+                  <a:solidFill>
+                    <a:schemeClr val="accent1"/>
+                  </a:solidFill>
+                </a:rPr>
+                <a:t>05</a:t>
+              </a:r>
+            </a:p>
+          </p:txBody>
+        </p:sp>
+        <p:sp>
+          <p:nvSpPr>
+            <p:cNvPr id="17" name="heading"/>
+            <p:cNvSpPr txBox="1"/>
+            <p:nvPr/>
+          </p:nvSpPr>
+          <p:spPr>
+            <a:xfrm>
+              <a:off x="5577840" y="3794760"/>
+              <a:ext cx="6062472" cy="457200"/>
+            </a:xfrm>
+            <a:prstGeom prst="rect">
+              <a:avLst/>
+            </a:prstGeom>
+            <a:noFill/>
+          </p:spPr>
+          <p:txBody>
+            <a:bodyPr wrap="square" lIns="0" tIns="0" rIns="0" bIns="0" rtlCol="0" anchor="ctr">
+              <a:normAutofit/>
+            </a:bodyPr>
+            <a:lstStyle/>
+            <a:p>
+              <a:pPr marL="0" indent="0" algn="l">
+                <a:buNone/>
+              </a:pPr>
+              <a:r>
+                <a:rPr lang="en-US" sz="2000" b="0" dirty="0">
+                  <a:solidFill>
+                    <a:schemeClr val="tx1"/>
+                  </a:solidFill>
+                </a:rPr>
+                <a:t>Data layouts</a:t>
+              </a:r>
+            </a:p>
+          </p:txBody>
+        </p:sp>
+      </p:grpSp>
+      <p:grpSp>
+        <p:nvGrpSpPr>
+          <p:cNvPr id="21" name="Agenda entry 6"/>
+          <p:cNvGrpSpPr/>
+          <p:nvPr/>
+        </p:nvGrpSpPr>
+        <p:grpSpPr>
+          <a:xfrm>
+            <a:off x="4846320" y="4526280"/>
+            <a:ext cx="6793992" cy="457200"/>
+            <a:chOff x="4846320" y="4526280"/>
+            <a:chExt cx="6793992" cy="457200"/>
+          </a:xfrm>
+        </p:grpSpPr>
+        <p:sp>
+          <p:nvSpPr>
+            <p:cNvPr id="19" name="number"/>
+            <p:cNvSpPr txBox="1"/>
+            <p:nvPr/>
+          </p:nvSpPr>
+          <p:spPr>
+            <a:xfrm>
+              <a:off x="4846320" y="4526280"/>
+              <a:ext cx="640080" cy="457200"/>
+            </a:xfrm>
+            <a:prstGeom prst="rect">
+              <a:avLst/>
+            </a:prstGeom>
+            <a:noFill/>
+          </p:spPr>
+          <p:txBody>
+            <a:bodyPr wrap="square" lIns="0" tIns="0" rIns="0" bIns="0" rtlCol="0" anchor="ctr">
+              <a:normAutofit/>
+            </a:bodyPr>
+            <a:lstStyle/>
+            <a:p>
+              <a:pPr marL="0" indent="0" algn="l">
+                <a:buNone/>
+              </a:pPr>
+              <a:r>
+                <a:rPr lang="en-US" sz="2000" b="1" dirty="0">
+                  <a:solidFill>
+                    <a:schemeClr val="accent1"/>
+                  </a:solidFill>
+                </a:rPr>
+                <a:t>06</a:t>
+              </a:r>
+            </a:p>
+          </p:txBody>
+        </p:sp>
+        <p:sp>
+          <p:nvSpPr>
+            <p:cNvPr id="20" name="heading"/>
+            <p:cNvSpPr txBox="1"/>
+            <p:nvPr/>
+          </p:nvSpPr>
+          <p:spPr>
+            <a:xfrm>
+              <a:off x="5577840" y="4526280"/>
+              <a:ext cx="6062472" cy="457200"/>
+            </a:xfrm>
+            <a:prstGeom prst="rect">
+              <a:avLst/>
+            </a:prstGeom>
+            <a:noFill/>
+          </p:spPr>
+          <p:txBody>
+            <a:bodyPr wrap="square" lIns="0" tIns="0" rIns="0" bIns="0" rtlCol="0" anchor="ctr">
+              <a:normAutofit/>
+            </a:bodyPr>
+            <a:lstStyle/>
+            <a:p>
+              <a:pPr marL="0" indent="0" algn="l">
+                <a:buNone/>
+              </a:pPr>
+              <a:r>
+                <a:rPr lang="en-US" sz="2000" b="0" dirty="0">
+                  <a:solidFill>
+                    <a:schemeClr val="tx1"/>
+                  </a:solidFill>
+                </a:rPr>
+                <a:t>Process, people and code</a:t>
+              </a:r>
+            </a:p>
+          </p:txBody>
+        </p:sp>
+      </p:grpSp>
+      <p:grpSp>
+        <p:nvGrpSpPr>
+          <p:cNvPr id="24" name="Agenda entry 7"/>
+          <p:cNvGrpSpPr/>
+          <p:nvPr/>
+        </p:nvGrpSpPr>
+        <p:grpSpPr>
+          <a:xfrm>
+            <a:off x="4846320" y="5257800"/>
+            <a:ext cx="6793992" cy="457200"/>
+            <a:chOff x="4846320" y="5257800"/>
+            <a:chExt cx="6793992" cy="457200"/>
+          </a:xfrm>
+        </p:grpSpPr>
+        <p:sp>
+          <p:nvSpPr>
+            <p:cNvPr id="22" name="number"/>
+            <p:cNvSpPr txBox="1"/>
+            <p:nvPr/>
+          </p:nvSpPr>
+          <p:spPr>
+            <a:xfrm>
+              <a:off x="4846320" y="5257800"/>
+              <a:ext cx="640080" cy="457200"/>
+            </a:xfrm>
+            <a:prstGeom prst="rect">
+              <a:avLst/>
+            </a:prstGeom>
+            <a:noFill/>
+          </p:spPr>
+          <p:txBody>
+            <a:bodyPr wrap="square" lIns="0" tIns="0" rIns="0" bIns="0" rtlCol="0" anchor="ctr">
+              <a:normAutofit/>
+            </a:bodyPr>
+            <a:lstStyle/>
+            <a:p>
+              <a:pPr marL="0" indent="0" algn="l">
+                <a:buNone/>
+              </a:pPr>
+              <a:r>
+                <a:rPr lang="en-US" sz="2000" b="1" dirty="0">
+                  <a:solidFill>
+                    <a:schemeClr val="accent1"/>
+                  </a:solidFill>
+                </a:rPr>
+                <a:t>07</a:t>
+              </a:r>
+            </a:p>
+          </p:txBody>
+        </p:sp>
+        <p:sp>
+          <p:nvSpPr>
+            <p:cNvPr id="23" name="heading"/>
+            <p:cNvSpPr txBox="1"/>
+            <p:nvPr/>
+          </p:nvSpPr>
+          <p:spPr>
+            <a:xfrm>
+              <a:off x="5577840" y="5257800"/>
+              <a:ext cx="6062472" cy="457200"/>
+            </a:xfrm>
+            <a:prstGeom prst="rect">
+              <a:avLst/>
+            </a:prstGeom>
+            <a:noFill/>
+          </p:spPr>
+          <p:txBody>
+            <a:bodyPr wrap="square" lIns="0" tIns="0" rIns="0" bIns="0" rtlCol="0" anchor="ctr">
+              <a:normAutofit/>
+            </a:bodyPr>
+            <a:lstStyle/>
+            <a:p>
+              <a:pPr marL="0" indent="0" algn="l">
+                <a:buNone/>
+              </a:pPr>
+              <a:r>
+                <a:rPr lang="en-US" sz="2000" b="0" dirty="0">
+                  <a:solidFill>
+                    <a:schemeClr val="tx1"/>
+                  </a:solidFill>
+                </a:rPr>
+                <a:t>Closings and free canvases</a:t>
+              </a:r>
+            </a:p>
+          </p:txBody>
+        </p:sp>
+      </p:grpSp>
     </p:spTree>
   </p:cSld>
   <p:clrMapOvr>
@@ -32239,7 +32698,7 @@
           <a:p>
             <a:pPr/>
             <a:r>
-              <a:t>-62%</a:t>
+              <a:t>62%</a:t>
             </a:r>
           </a:p>
         </p:txBody>
@@ -32371,7 +32830,7 @@
           <a:p>
             <a:pPr/>
             <a:r>
-              <a:t>x3</a:t>
+              <a:t>3x</a:t>
             </a:r>
           </a:p>
         </p:txBody>
@@ -32462,7 +32921,7 @@
       </p:sp>
       <p:sp>
         <p:nvSpPr>
-          <p:cNvPr id="3" name="Text Placeholder 2"/>
+          <p:cNvPr id="3" name="number"/>
           <p:cNvSpPr>
             <a:spLocks noGrp="1"/>
           </p:cNvSpPr>
@@ -32484,7 +32943,7 @@
       </p:sp>
       <p:sp>
         <p:nvSpPr>
-          <p:cNvPr id="4" name="Text Placeholder 3"/>
+          <p:cNvPr id="4" name="label"/>
           <p:cNvSpPr>
             <a:spLocks noGrp="1"/>
           </p:cNvSpPr>
@@ -32506,7 +32965,7 @@
       </p:sp>
       <p:sp>
         <p:nvSpPr>
-          <p:cNvPr id="5" name="Text Placeholder 4"/>
+          <p:cNvPr id="5" name="body"/>
           <p:cNvSpPr>
             <a:spLocks noGrp="1"/>
           </p:cNvSpPr>
@@ -32630,9 +33089,25 @@
             <p:ph type="body" idx="103"/>
           </p:nvPr>
         </p:nvSpPr>
-        <p:spPr/>
-        <p:txBody>
-          <a:bodyPr/>
+        <p:spPr>
+          <a:xfrm>
+            <a:off x="8275320" y="1691640"/>
+            <a:ext cx="3367735" cy="4343400"/>
+          </a:xfrm>
+          <a:prstGeom prst="roundRect">
+            <a:avLst>
+              <a:gd name="adj" fmla="val 4344"/>
+            </a:avLst>
+          </a:prstGeom>
+          <a:solidFill>
+            <a:schemeClr val="bg2"/>
+          </a:solidFill>
+          <a:ln>
+            <a:noFill/>
+          </a:ln>
+        </p:spPr>
+        <p:txBody>
+          <a:bodyPr lIns="320040" tIns="365760" rIns="304495" bIns="320040"/>
           <a:lstStyle/>
           <a:p>
             <a:pPr/>
@@ -34199,7 +34674,7 @@
         </p:nvGraphicFramePr>
         <p:xfrm>
           <a:off x="548640" y="1691640"/>
-          <a:ext cx="11094415" cy="3200400"/>
+          <a:ext cx="11094415" cy="4114800"/>
         </p:xfrm>
         <a:graphic>
           <a:graphicData uri="http://schemas.openxmlformats.org/drawingml/2006/table">
@@ -34208,9 +34683,11 @@
                 <a:tableStyleId>{5C22544A-7EE6-4342-B048-85BDC9FD1C3A}</a:tableStyleId>
               </a:tblPr>
               <a:tblGrid>
-                <a:gridCol w="3698138"/>
-                <a:gridCol w="3698138"/>
-                <a:gridCol w="3698139"/>
+                <a:gridCol w="2218883"/>
+                <a:gridCol w="2218883"/>
+                <a:gridCol w="2218883"/>
+                <a:gridCol w="2218883"/>
+                <a:gridCol w="2218883"/>
               </a:tblGrid>
               <a:tr h="457200">
                 <a:tc>
@@ -34220,7 +34697,7 @@
                     <a:p>
                       <a:r>
                         <a:rPr sz="1400" b="1"/>
-                        <a:t>Family</a:t>
+                        <a:t>Layout family</a:t>
                       </a:r>
                     </a:p>
                   </a:txBody>
@@ -34252,8 +34729,54 @@
                   </a:txBody>
                   <a:tcPr marL="137160" marR="137160" marT="73152" marB="73152" anchor="ctr"/>
                 </a:tc>
+                <a:tc>
+                  <a:txBody>
+                    <a:bodyPr/>
+                    <a:lstStyle/>
+                    <a:p>
+                      <a:r>
+                        <a:rPr sz="1400" b="1"/>
+                        <a:t>Content</a:t>
+                      </a:r>
+                    </a:p>
+                  </a:txBody>
+                  <a:tcPr marL="137160" marR="137160" marT="73152" marB="73152" anchor="ctr"/>
+                </a:tc>
+                <a:tc>
+                  <a:txBody>
+                    <a:bodyPr/>
+                    <a:lstStyle/>
+                    <a:p>
+                      <a:r>
+                        <a:rPr sz="1400" b="1"/>
+                        <a:t>Status</a:t>
+                      </a:r>
+                    </a:p>
+                  </a:txBody>
+                  <a:tcPr marL="137160" marR="137160" marT="73152" marB="73152" anchor="ctr"/>
+                </a:tc>
               </a:tr>
               <a:tr h="457200">
+                <a:tc>
+                  <a:txBody>
+                    <a:bodyPr/>
+                    <a:lstStyle/>
+                    <a:p>
+                      <a:endParaRPr sz="1400" b="0"/>
+                    </a:p>
+                  </a:txBody>
+                  <a:tcPr marL="137160" marR="137160" marT="73152" marB="73152" anchor="ctr"/>
+                </a:tc>
+                <a:tc>
+                  <a:txBody>
+                    <a:bodyPr/>
+                    <a:lstStyle/>
+                    <a:p>
+                      <a:endParaRPr sz="1400" b="0"/>
+                    </a:p>
+                  </a:txBody>
+                  <a:tcPr marL="137160" marR="137160" marT="73152" marB="73152" anchor="ctr"/>
+                </a:tc>
                 <a:tc>
                   <a:txBody>
                     <a:bodyPr/>
@@ -34316,8 +34839,48 @@
                   </a:txBody>
                   <a:tcPr marL="137160" marR="137160" marT="73152" marB="73152" anchor="ctr"/>
                 </a:tc>
+                <a:tc>
+                  <a:txBody>
+                    <a:bodyPr/>
+                    <a:lstStyle/>
+                    <a:p>
+                      <a:endParaRPr sz="1400" b="0"/>
+                    </a:p>
+                  </a:txBody>
+                  <a:tcPr marL="137160" marR="137160" marT="73152" marB="73152" anchor="ctr"/>
+                </a:tc>
+                <a:tc>
+                  <a:txBody>
+                    <a:bodyPr/>
+                    <a:lstStyle/>
+                    <a:p>
+                      <a:endParaRPr sz="1400" b="0"/>
+                    </a:p>
+                  </a:txBody>
+                  <a:tcPr marL="137160" marR="137160" marT="73152" marB="73152" anchor="ctr"/>
+                </a:tc>
               </a:tr>
               <a:tr h="457200">
+                <a:tc>
+                  <a:txBody>
+                    <a:bodyPr/>
+                    <a:lstStyle/>
+                    <a:p>
+                      <a:endParaRPr sz="1400" b="0"/>
+                    </a:p>
+                  </a:txBody>
+                  <a:tcPr marL="137160" marR="137160" marT="73152" marB="73152" anchor="ctr"/>
+                </a:tc>
+                <a:tc>
+                  <a:txBody>
+                    <a:bodyPr/>
+                    <a:lstStyle/>
+                    <a:p>
+                      <a:endParaRPr sz="1400" b="0"/>
+                    </a:p>
+                  </a:txBody>
+                  <a:tcPr marL="137160" marR="137160" marT="73152" marB="73152" anchor="ctr"/>
+                </a:tc>
                 <a:tc>
                   <a:txBody>
                     <a:bodyPr/>
@@ -34380,8 +34943,48 @@
                   </a:txBody>
                   <a:tcPr marL="137160" marR="137160" marT="73152" marB="73152" anchor="ctr"/>
                 </a:tc>
+                <a:tc>
+                  <a:txBody>
+                    <a:bodyPr/>
+                    <a:lstStyle/>
+                    <a:p>
+                      <a:endParaRPr sz="1400" b="0"/>
+                    </a:p>
+                  </a:txBody>
+                  <a:tcPr marL="137160" marR="137160" marT="73152" marB="73152" anchor="ctr"/>
+                </a:tc>
+                <a:tc>
+                  <a:txBody>
+                    <a:bodyPr/>
+                    <a:lstStyle/>
+                    <a:p>
+                      <a:endParaRPr sz="1400" b="0"/>
+                    </a:p>
+                  </a:txBody>
+                  <a:tcPr marL="137160" marR="137160" marT="73152" marB="73152" anchor="ctr"/>
+                </a:tc>
               </a:tr>
               <a:tr h="457200">
+                <a:tc>
+                  <a:txBody>
+                    <a:bodyPr/>
+                    <a:lstStyle/>
+                    <a:p>
+                      <a:endParaRPr sz="1400" b="0"/>
+                    </a:p>
+                  </a:txBody>
+                  <a:tcPr marL="137160" marR="137160" marT="73152" marB="73152" anchor="ctr"/>
+                </a:tc>
+                <a:tc>
+                  <a:txBody>
+                    <a:bodyPr/>
+                    <a:lstStyle/>
+                    <a:p>
+                      <a:endParaRPr sz="1400" b="0"/>
+                    </a:p>
+                  </a:txBody>
+                  <a:tcPr marL="137160" marR="137160" marT="73152" marB="73152" anchor="ctr"/>
+                </a:tc>
                 <a:tc>
                   <a:txBody>
                     <a:bodyPr/>
@@ -34444,6 +35047,130 @@
                   </a:txBody>
                   <a:tcPr marL="137160" marR="137160" marT="73152" marB="73152" anchor="ctr"/>
                 </a:tc>
+                <a:tc>
+                  <a:txBody>
+                    <a:bodyPr/>
+                    <a:lstStyle/>
+                    <a:p>
+                      <a:endParaRPr sz="1400" b="0"/>
+                    </a:p>
+                  </a:txBody>
+                  <a:tcPr marL="137160" marR="137160" marT="73152" marB="73152" anchor="ctr"/>
+                </a:tc>
+                <a:tc>
+                  <a:txBody>
+                    <a:bodyPr/>
+                    <a:lstStyle/>
+                    <a:p>
+                      <a:endParaRPr sz="1400" b="0"/>
+                    </a:p>
+                  </a:txBody>
+                  <a:tcPr marL="137160" marR="137160" marT="73152" marB="73152" anchor="ctr"/>
+                </a:tc>
+              </a:tr>
+              <a:tr h="457200">
+                <a:tc>
+                  <a:txBody>
+                    <a:bodyPr/>
+                    <a:lstStyle/>
+                    <a:p>
+                      <a:endParaRPr sz="1400" b="0"/>
+                    </a:p>
+                  </a:txBody>
+                  <a:tcPr marL="137160" marR="137160" marT="73152" marB="73152" anchor="ctr"/>
+                </a:tc>
+                <a:tc>
+                  <a:txBody>
+                    <a:bodyPr/>
+                    <a:lstStyle/>
+                    <a:p>
+                      <a:endParaRPr sz="1400" b="0"/>
+                    </a:p>
+                  </a:txBody>
+                  <a:tcPr marL="137160" marR="137160" marT="73152" marB="73152" anchor="ctr"/>
+                </a:tc>
+                <a:tc>
+                  <a:txBody>
+                    <a:bodyPr/>
+                    <a:lstStyle/>
+                    <a:p>
+                      <a:endParaRPr sz="1400" b="0"/>
+                    </a:p>
+                  </a:txBody>
+                  <a:tcPr marL="137160" marR="137160" marT="73152" marB="73152" anchor="ctr"/>
+                </a:tc>
+                <a:tc>
+                  <a:txBody>
+                    <a:bodyPr/>
+                    <a:lstStyle/>
+                    <a:p>
+                      <a:endParaRPr sz="1400" b="0"/>
+                    </a:p>
+                  </a:txBody>
+                  <a:tcPr marL="137160" marR="137160" marT="73152" marB="73152" anchor="ctr"/>
+                </a:tc>
+                <a:tc>
+                  <a:txBody>
+                    <a:bodyPr/>
+                    <a:lstStyle/>
+                    <a:p>
+                      <a:endParaRPr sz="1400" b="0"/>
+                    </a:p>
+                  </a:txBody>
+                  <a:tcPr marL="137160" marR="137160" marT="73152" marB="73152" anchor="ctr"/>
+                </a:tc>
+              </a:tr>
+              <a:tr h="457200">
+                <a:tc>
+                  <a:txBody>
+                    <a:bodyPr/>
+                    <a:lstStyle/>
+                    <a:p>
+                      <a:endParaRPr sz="1400" b="0"/>
+                    </a:p>
+                  </a:txBody>
+                  <a:tcPr marL="137160" marR="137160" marT="73152" marB="73152" anchor="ctr"/>
+                </a:tc>
+                <a:tc>
+                  <a:txBody>
+                    <a:bodyPr/>
+                    <a:lstStyle/>
+                    <a:p>
+                      <a:endParaRPr sz="1400" b="0"/>
+                    </a:p>
+                  </a:txBody>
+                  <a:tcPr marL="137160" marR="137160" marT="73152" marB="73152" anchor="ctr"/>
+                </a:tc>
+                <a:tc>
+                  <a:txBody>
+                    <a:bodyPr/>
+                    <a:lstStyle/>
+                    <a:p>
+                      <a:endParaRPr sz="1400" b="0"/>
+                    </a:p>
+                  </a:txBody>
+                  <a:tcPr marL="137160" marR="137160" marT="73152" marB="73152" anchor="ctr"/>
+                </a:tc>
+                <a:tc>
+                  <a:txBody>
+                    <a:bodyPr/>
+                    <a:lstStyle/>
+                    <a:p>
+                      <a:endParaRPr sz="1400" b="0"/>
+                    </a:p>
+                  </a:txBody>
+                  <a:tcPr marL="137160" marR="137160" marT="73152" marB="73152" anchor="ctr"/>
+                </a:tc>
+                <a:tc>
+                  <a:txBody>
+                    <a:bodyPr/>
+                    <a:lstStyle/>
+                    <a:p>
+                      <a:endParaRPr sz="1400" b="0"/>
+                    </a:p>
+                  </a:txBody>
+                  <a:tcPr marL="137160" marR="137160" marT="73152" marB="73152" anchor="ctr"/>
+                </a:tc>
               </a:tr>
             </a:tbl>
           </a:graphicData>
@@ -34469,7 +35196,7 @@
       <p:grpSpPr/>
       <p:sp>
         <p:nvSpPr>
-          <p:cNvPr id="2" name="Text Placeholder 1"/>
+          <p:cNvPr id="2" name="number"/>
           <p:cNvSpPr>
             <a:spLocks noGrp="1"/>
           </p:cNvSpPr>
@@ -34513,7 +35240,7 @@
       </p:sp>
       <p:sp>
         <p:nvSpPr>
-          <p:cNvPr id="4" name="Text Placeholder 3"/>
+          <p:cNvPr id="4" name="subtitle"/>
           <p:cNvSpPr>
             <a:spLocks noGrp="1"/>
           </p:cNvSpPr>
@@ -35062,7 +35789,7 @@
           <a:p>
             <a:pPr/>
             <a:r>
-              <a:t>Q1 2026</a:t>
+              <a:t>2024</a:t>
             </a:r>
           </a:p>
         </p:txBody>
@@ -35128,7 +35855,7 @@
           <a:p>
             <a:pPr/>
             <a:r>
-              <a:t>Q2 2026</a:t>
+              <a:t>2025</a:t>
             </a:r>
           </a:p>
         </p:txBody>
@@ -35194,7 +35921,7 @@
           <a:p>
             <a:pPr/>
             <a:r>
-              <a:t>Q3 2026</a:t>
+              <a:t>2026</a:t>
             </a:r>
           </a:p>
         </p:txBody>
@@ -35260,7 +35987,7 @@
           <a:p>
             <a:pPr/>
             <a:r>
-              <a:t>Q4 2026</a:t>
+              <a:t>2027</a:t>
             </a:r>
           </a:p>
         </p:txBody>
@@ -35326,7 +36053,7 @@
           <a:p>
             <a:pPr/>
             <a:r>
-              <a:t>2027</a:t>
+              <a:t>2028</a:t>
             </a:r>
           </a:p>
         </p:txBody>
@@ -35667,9 +36394,25 @@
             <p:ph type="body" idx="111"/>
           </p:nvPr>
         </p:nvSpPr>
-        <p:spPr/>
-        <p:txBody>
-          <a:bodyPr/>
+        <p:spPr>
+          <a:xfrm>
+            <a:off x="8458200" y="1691640"/>
+            <a:ext cx="3184855" cy="4343400"/>
+          </a:xfrm>
+          <a:prstGeom prst="roundRect">
+            <a:avLst>
+              <a:gd name="adj" fmla="val 4593"/>
+            </a:avLst>
+          </a:prstGeom>
+          <a:solidFill>
+            <a:schemeClr val="bg2"/>
+          </a:solidFill>
+          <a:ln>
+            <a:noFill/>
+          </a:ln>
+        </p:spPr>
+        <p:txBody>
+          <a:bodyPr lIns="320040" tIns="365760" rIns="304495" bIns="320040"/>
           <a:lstStyle/>
           <a:p>
             <a:pPr/>
@@ -37014,7 +37757,7 @@
       <p:grpSpPr/>
       <p:sp>
         <p:nvSpPr>
-          <p:cNvPr id="2" name="Text Placeholder 1"/>
+          <p:cNvPr id="2" name="number"/>
           <p:cNvSpPr>
             <a:spLocks noGrp="1"/>
           </p:cNvSpPr>
@@ -37058,7 +37801,7 @@
       </p:sp>
       <p:sp>
         <p:nvSpPr>
-          <p:cNvPr id="4" name="Text Placeholder 3"/>
+          <p:cNvPr id="4" name="subtitle"/>
           <p:cNvSpPr>
             <a:spLocks noGrp="1"/>
           </p:cNvSpPr>
@@ -37098,7 +37841,7 @@
       <p:grpSpPr/>
       <p:sp>
         <p:nvSpPr>
-          <p:cNvPr id="2" name="Text Placeholder 1"/>
+          <p:cNvPr id="2" name="number"/>
           <p:cNvSpPr>
             <a:spLocks noGrp="1"/>
           </p:cNvSpPr>
@@ -37142,7 +37885,7 @@
       </p:sp>
       <p:sp>
         <p:nvSpPr>
-          <p:cNvPr id="4" name="Text Placeholder 3"/>
+          <p:cNvPr id="4" name="subtitle"/>
           <p:cNvSpPr>
             <a:spLocks noGrp="1"/>
           </p:cNvSpPr>

</xml_diff>